<commit_message>
fix: preserve portal grounding boundaries
</commit_message>
<xml_diff>
--- a/docs/presentations/BT_CAP_Midterm_2026-10-19.pptx
+++ b/docs/presentations/BT_CAP_Midterm_2026-10-19.pptx
@@ -2,19 +2,19 @@
 <file path=ppt/presentation.xml><?xml version="1.0" encoding="utf-8"?>
 <p:presentation xmlns:p="http://schemas.openxmlformats.org/presentationml/2006/main">
   <p:sldMasterIdLst>
-    <p:sldMasterId xmlns:r="http://schemas.openxmlformats.org/officeDocument/2006/relationships" id="2147483648" r:id="Rc056cd8755094a4a"/>
+    <p:sldMasterId xmlns:r="http://schemas.openxmlformats.org/officeDocument/2006/relationships" id="2147483648" r:id="Re02ede02dff14d2b"/>
   </p:sldMasterIdLst>
   <p:notesMasterIdLst>
-    <p:notesMasterId xmlns:r="http://schemas.openxmlformats.org/officeDocument/2006/relationships" r:id="Ra29112baeb5f4500"/>
+    <p:notesMasterId xmlns:r="http://schemas.openxmlformats.org/officeDocument/2006/relationships" r:id="R41dcff62eeed4e56"/>
   </p:notesMasterIdLst>
   <p:sldIdLst>
-    <p:sldId xmlns:r="http://schemas.openxmlformats.org/officeDocument/2006/relationships" id="256" r:id="R89621e62435f4de2"/>
-    <p:sldId xmlns:r="http://schemas.openxmlformats.org/officeDocument/2006/relationships" id="257" r:id="R1ccf5e7d65774150"/>
-    <p:sldId xmlns:r="http://schemas.openxmlformats.org/officeDocument/2006/relationships" id="258" r:id="Rf7367fd879454aac"/>
-    <p:sldId xmlns:r="http://schemas.openxmlformats.org/officeDocument/2006/relationships" id="259" r:id="Rf1d8cd9e3753492f"/>
-    <p:sldId xmlns:r="http://schemas.openxmlformats.org/officeDocument/2006/relationships" id="260" r:id="Ra14a88996fa64e4f"/>
-    <p:sldId xmlns:r="http://schemas.openxmlformats.org/officeDocument/2006/relationships" id="261" r:id="Rd4f22abbec274c1f"/>
-    <p:sldId xmlns:r="http://schemas.openxmlformats.org/officeDocument/2006/relationships" id="262" r:id="R8d964b7cf70642a8"/>
+    <p:sldId xmlns:r="http://schemas.openxmlformats.org/officeDocument/2006/relationships" id="256" r:id="R436e167b386d43d9"/>
+    <p:sldId xmlns:r="http://schemas.openxmlformats.org/officeDocument/2006/relationships" id="257" r:id="R8b475a61aa204b20"/>
+    <p:sldId xmlns:r="http://schemas.openxmlformats.org/officeDocument/2006/relationships" id="258" r:id="R7cb63d9edc2c473a"/>
+    <p:sldId xmlns:r="http://schemas.openxmlformats.org/officeDocument/2006/relationships" id="259" r:id="Ra769585128084a36"/>
+    <p:sldId xmlns:r="http://schemas.openxmlformats.org/officeDocument/2006/relationships" id="260" r:id="R89c4bd7ffb544cad"/>
+    <p:sldId xmlns:r="http://schemas.openxmlformats.org/officeDocument/2006/relationships" id="261" r:id="R9f3376b7d5514592"/>
+    <p:sldId xmlns:r="http://schemas.openxmlformats.org/officeDocument/2006/relationships" id="262" r:id="R72e1435ac2fc4172"/>
   </p:sldIdLst>
   <p:sldSz cx="12192000" cy="6858000"/>
   <p:notesSz cx="6858000" cy="9144000"/>
@@ -980,7 +980,7 @@
           <p:cNvPr id="3" name="Title">
             <a:extLst xmlns:a="http://schemas.openxmlformats.org/drawingml/2006/main">
               <a:ext uri="{FF2B5EF4-FFF2-40B4-BE49-F238E27FC236}">
-                <a16:creationId xmlns:a16="http://schemas.microsoft.com/office/drawing/2014/main" id="{8E848821-2FA1-43AD-AC38-5896A143DD0C}"/>
+                <a16:creationId xmlns:a16="http://schemas.microsoft.com/office/drawing/2014/main" id="{15683EDB-52CA-4950-990C-2BA2A3A2F80E}"/>
               </a:ext>
             </a:extLst>
           </p:cNvPr>
@@ -1209,7 +1209,7 @@
           <p:cNvPr id="2" name="Subtitle">
             <a:extLst xmlns:a="http://schemas.openxmlformats.org/drawingml/2006/main">
               <a:ext uri="{FF2B5EF4-FFF2-40B4-BE49-F238E27FC236}">
-                <a16:creationId xmlns:a16="http://schemas.microsoft.com/office/drawing/2014/main" id="{02199FBA-3086-4C9A-B245-24212137133C}"/>
+                <a16:creationId xmlns:a16="http://schemas.microsoft.com/office/drawing/2014/main" id="{20495DF0-B343-41FC-9D3F-36A05325E23A}"/>
               </a:ext>
             </a:extLst>
           </p:cNvPr>
@@ -1455,7 +1455,7 @@
           <p:cNvPr id="2" name="Section title">
             <a:extLst xmlns:a="http://schemas.openxmlformats.org/drawingml/2006/main">
               <a:ext uri="{FF2B5EF4-FFF2-40B4-BE49-F238E27FC236}">
-                <a16:creationId xmlns:a16="http://schemas.microsoft.com/office/drawing/2014/main" id="{A1C76631-E138-4E3C-8690-E31842B4E0EA}"/>
+                <a16:creationId xmlns:a16="http://schemas.microsoft.com/office/drawing/2014/main" id="{2F953DDE-9ECA-4211-8C32-360D307889F6}"/>
               </a:ext>
             </a:extLst>
           </p:cNvPr>
@@ -1701,7 +1701,7 @@
           <p:cNvPr id="3" name="Title">
             <a:extLst xmlns:a="http://schemas.openxmlformats.org/drawingml/2006/main">
               <a:ext uri="{FF2B5EF4-FFF2-40B4-BE49-F238E27FC236}">
-                <a16:creationId xmlns:a16="http://schemas.microsoft.com/office/drawing/2014/main" id="{E162D0BB-2BDC-4A52-BC94-CC13C9650CD4}"/>
+                <a16:creationId xmlns:a16="http://schemas.microsoft.com/office/drawing/2014/main" id="{50DA6EFF-3EC9-4B6F-A92F-0E66C40C2A43}"/>
               </a:ext>
             </a:extLst>
           </p:cNvPr>
@@ -1930,7 +1930,7 @@
           <p:cNvPr id="2" name="Body">
             <a:extLst xmlns:a="http://schemas.openxmlformats.org/drawingml/2006/main">
               <a:ext uri="{FF2B5EF4-FFF2-40B4-BE49-F238E27FC236}">
-                <a16:creationId xmlns:a16="http://schemas.microsoft.com/office/drawing/2014/main" id="{44257500-A9D1-4AAA-93CD-E1A2F5748857}"/>
+                <a16:creationId xmlns:a16="http://schemas.microsoft.com/office/drawing/2014/main" id="{28924A78-FEC6-4A7F-BC6C-539B95E4DEA8}"/>
               </a:ext>
             </a:extLst>
           </p:cNvPr>
@@ -2176,7 +2176,7 @@
           <p:cNvPr id="4" name="Title">
             <a:extLst xmlns:a="http://schemas.openxmlformats.org/drawingml/2006/main">
               <a:ext uri="{FF2B5EF4-FFF2-40B4-BE49-F238E27FC236}">
-                <a16:creationId xmlns:a16="http://schemas.microsoft.com/office/drawing/2014/main" id="{56943BEE-0F2C-4245-8F88-3D7A03898901}"/>
+                <a16:creationId xmlns:a16="http://schemas.microsoft.com/office/drawing/2014/main" id="{FBB4D5F0-723E-4A25-A4F4-90A532E57EC6}"/>
               </a:ext>
             </a:extLst>
           </p:cNvPr>
@@ -2405,7 +2405,7 @@
           <p:cNvPr id="2" name="Left column">
             <a:extLst xmlns:a="http://schemas.openxmlformats.org/drawingml/2006/main">
               <a:ext uri="{FF2B5EF4-FFF2-40B4-BE49-F238E27FC236}">
-                <a16:creationId xmlns:a16="http://schemas.microsoft.com/office/drawing/2014/main" id="{C3BADE19-36FE-4D4E-BBB2-D61767A9160D}"/>
+                <a16:creationId xmlns:a16="http://schemas.microsoft.com/office/drawing/2014/main" id="{4F689773-ACF6-4739-B7C2-A44DD2F1F73B}"/>
               </a:ext>
             </a:extLst>
           </p:cNvPr>
@@ -2634,7 +2634,7 @@
           <p:cNvPr id="3" name="Right column">
             <a:extLst xmlns:a="http://schemas.openxmlformats.org/drawingml/2006/main">
               <a:ext uri="{FF2B5EF4-FFF2-40B4-BE49-F238E27FC236}">
-                <a16:creationId xmlns:a16="http://schemas.microsoft.com/office/drawing/2014/main" id="{BF015129-60E3-4155-BF6B-F9D3B7517263}"/>
+                <a16:creationId xmlns:a16="http://schemas.microsoft.com/office/drawing/2014/main" id="{C1A1BBEE-C84C-4777-A34C-5A86B1544534}"/>
               </a:ext>
             </a:extLst>
           </p:cNvPr>
@@ -2880,7 +2880,7 @@
           <p:cNvPr id="3" name="Title">
             <a:extLst xmlns:a="http://schemas.openxmlformats.org/drawingml/2006/main">
               <a:ext uri="{FF2B5EF4-FFF2-40B4-BE49-F238E27FC236}">
-                <a16:creationId xmlns:a16="http://schemas.microsoft.com/office/drawing/2014/main" id="{3AC10847-B374-4C9E-8829-B11F6FDC68D4}"/>
+                <a16:creationId xmlns:a16="http://schemas.microsoft.com/office/drawing/2014/main" id="{DEC17963-4A6C-4364-99C6-D71710FAB237}"/>
               </a:ext>
             </a:extLst>
           </p:cNvPr>
@@ -3109,7 +3109,7 @@
           <p:cNvPr id="2" name="Left column">
             <a:extLst xmlns:a="http://schemas.openxmlformats.org/drawingml/2006/main">
               <a:ext uri="{FF2B5EF4-FFF2-40B4-BE49-F238E27FC236}">
-                <a16:creationId xmlns:a16="http://schemas.microsoft.com/office/drawing/2014/main" id="{804238F4-088D-4414-BB4A-CC8370730FF1}"/>
+                <a16:creationId xmlns:a16="http://schemas.microsoft.com/office/drawing/2014/main" id="{A8CB9ECA-3A28-447C-A760-582D7D093B71}"/>
               </a:ext>
             </a:extLst>
           </p:cNvPr>
@@ -3376,12 +3376,12 @@
   </p:cSld>
   <p:clrMap bg1="lt1" tx1="dk1" bg2="lt2" tx2="dk2" accent1="accent1" accent2="accent2" accent3="accent3" accent4="accent4" accent5="accent5" accent6="accent6" hlink="hlink" folHlink="folHlink"/>
   <p:sldLayoutIdLst>
-    <p:sldLayoutId xmlns:r="http://schemas.openxmlformats.org/officeDocument/2006/relationships" id="2147483649" r:id="R16767d7a255e4701"/>
-    <p:sldLayoutId xmlns:r="http://schemas.openxmlformats.org/officeDocument/2006/relationships" id="2147483650" r:id="R746ef7d2b38841e4"/>
-    <p:sldLayoutId xmlns:r="http://schemas.openxmlformats.org/officeDocument/2006/relationships" id="2147483651" r:id="R96f00e3422ab47fe"/>
-    <p:sldLayoutId xmlns:r="http://schemas.openxmlformats.org/officeDocument/2006/relationships" id="2147483652" r:id="R38a2d55639e049c1"/>
-    <p:sldLayoutId xmlns:r="http://schemas.openxmlformats.org/officeDocument/2006/relationships" id="2147483653" r:id="R7da4110a46bc4a50"/>
-    <p:sldLayoutId xmlns:r="http://schemas.openxmlformats.org/officeDocument/2006/relationships" id="2147483654" r:id="Rabae4f6c852d4a7b"/>
+    <p:sldLayoutId xmlns:r="http://schemas.openxmlformats.org/officeDocument/2006/relationships" id="2147483649" r:id="Ra87003a84f6940f7"/>
+    <p:sldLayoutId xmlns:r="http://schemas.openxmlformats.org/officeDocument/2006/relationships" id="2147483650" r:id="Rbad1d3bf59154642"/>
+    <p:sldLayoutId xmlns:r="http://schemas.openxmlformats.org/officeDocument/2006/relationships" id="2147483651" r:id="R760016082c394550"/>
+    <p:sldLayoutId xmlns:r="http://schemas.openxmlformats.org/officeDocument/2006/relationships" id="2147483652" r:id="R447813cd4745447f"/>
+    <p:sldLayoutId xmlns:r="http://schemas.openxmlformats.org/officeDocument/2006/relationships" id="2147483653" r:id="Rc398066297224897"/>
+    <p:sldLayoutId xmlns:r="http://schemas.openxmlformats.org/officeDocument/2006/relationships" id="2147483654" r:id="Rb48c4d5350d14da5"/>
   </p:sldLayoutIdLst>
   <p:txStyles>
     <p:titleStyle>
@@ -3932,7 +3932,7 @@
           <p:cNvPr id="26" name="">
             <a:extLst xmlns:a="http://schemas.openxmlformats.org/drawingml/2006/main">
               <a:ext uri="{FF2B5EF4-FFF2-40B4-BE49-F238E27FC236}">
-                <a16:creationId xmlns:a16="http://schemas.microsoft.com/office/drawing/2014/main" id="{2F5DFA39-57E7-4FFE-A5DE-2061759F76F7}"/>
+                <a16:creationId xmlns:a16="http://schemas.microsoft.com/office/drawing/2014/main" id="{056CB710-2984-4063-B914-4668805979A9}"/>
               </a:ext>
             </a:extLst>
           </p:cNvPr>
@@ -3963,7 +3963,7 @@
           <p:cNvPr id="2" name="">
             <a:extLst xmlns:a="http://schemas.openxmlformats.org/drawingml/2006/main">
               <a:ext uri="{FF2B5EF4-FFF2-40B4-BE49-F238E27FC236}">
-                <a16:creationId xmlns:a16="http://schemas.microsoft.com/office/drawing/2014/main" id="{FB359FE3-7A76-4C72-82F8-1E3747735474}"/>
+                <a16:creationId xmlns:a16="http://schemas.microsoft.com/office/drawing/2014/main" id="{39AEA399-1171-49C8-A346-4D463148225E}"/>
               </a:ext>
             </a:extLst>
           </p:cNvPr>
@@ -4084,7 +4084,7 @@
           <p:cNvPr id="3" name="">
             <a:extLst xmlns:a="http://schemas.openxmlformats.org/drawingml/2006/main">
               <a:ext uri="{FF2B5EF4-FFF2-40B4-BE49-F238E27FC236}">
-                <a16:creationId xmlns:a16="http://schemas.microsoft.com/office/drawing/2014/main" id="{FD9CF1D0-B035-4EE6-875C-45583FCFFFBB}"/>
+                <a16:creationId xmlns:a16="http://schemas.microsoft.com/office/drawing/2014/main" id="{DD5139EB-713F-4081-9EF5-B4EFDF3C72FF}"/>
               </a:ext>
             </a:extLst>
           </p:cNvPr>
@@ -4222,7 +4222,7 @@
           <p:cNvPr id="4" name="">
             <a:extLst xmlns:a="http://schemas.openxmlformats.org/drawingml/2006/main">
               <a:ext uri="{FF2B5EF4-FFF2-40B4-BE49-F238E27FC236}">
-                <a16:creationId xmlns:a16="http://schemas.microsoft.com/office/drawing/2014/main" id="{1FA61858-4A49-4A7C-9938-A933EFB08F8D}"/>
+                <a16:creationId xmlns:a16="http://schemas.microsoft.com/office/drawing/2014/main" id="{4BEE8FCE-02F8-42B0-99E4-5734D2BFD5DB}"/>
               </a:ext>
             </a:extLst>
           </p:cNvPr>
@@ -4343,7 +4343,7 @@
           <p:cNvPr id="5" name="">
             <a:extLst xmlns:a="http://schemas.openxmlformats.org/drawingml/2006/main">
               <a:ext uri="{FF2B5EF4-FFF2-40B4-BE49-F238E27FC236}">
-                <a16:creationId xmlns:a16="http://schemas.microsoft.com/office/drawing/2014/main" id="{7672EBDB-376F-48B5-B0E4-5CE72B1CD58A}"/>
+                <a16:creationId xmlns:a16="http://schemas.microsoft.com/office/drawing/2014/main" id="{F5010AB1-F473-40BC-902F-7DA14E963A6C}"/>
               </a:ext>
             </a:extLst>
           </p:cNvPr>
@@ -4378,7 +4378,7 @@
           <p:cNvPr id="6" name="">
             <a:extLst xmlns:a="http://schemas.openxmlformats.org/drawingml/2006/main">
               <a:ext uri="{FF2B5EF4-FFF2-40B4-BE49-F238E27FC236}">
-                <a16:creationId xmlns:a16="http://schemas.microsoft.com/office/drawing/2014/main" id="{E1ADB6A1-9D12-4CDA-8FA8-7DA10BB098FE}"/>
+                <a16:creationId xmlns:a16="http://schemas.microsoft.com/office/drawing/2014/main" id="{A8A8EDAF-5281-4B88-8DE0-1D562EA3716C}"/>
               </a:ext>
             </a:extLst>
           </p:cNvPr>
@@ -4411,7 +4411,7 @@
           <p:cNvPr id="7" name="">
             <a:extLst xmlns:a="http://schemas.openxmlformats.org/drawingml/2006/main">
               <a:ext uri="{FF2B5EF4-FFF2-40B4-BE49-F238E27FC236}">
-                <a16:creationId xmlns:a16="http://schemas.microsoft.com/office/drawing/2014/main" id="{FE157F0C-7EA5-40C7-AA92-B94F5AFF4222}"/>
+                <a16:creationId xmlns:a16="http://schemas.microsoft.com/office/drawing/2014/main" id="{D14BBC8E-FAD6-4CD1-82CF-8D82C28DA7D1}"/>
               </a:ext>
             </a:extLst>
           </p:cNvPr>
@@ -4532,7 +4532,7 @@
           <p:cNvPr id="8" name="">
             <a:extLst xmlns:a="http://schemas.openxmlformats.org/drawingml/2006/main">
               <a:ext uri="{FF2B5EF4-FFF2-40B4-BE49-F238E27FC236}">
-                <a16:creationId xmlns:a16="http://schemas.microsoft.com/office/drawing/2014/main" id="{5FB8A617-0603-459E-9789-153615BB5329}"/>
+                <a16:creationId xmlns:a16="http://schemas.microsoft.com/office/drawing/2014/main" id="{CF992982-FC15-4755-B221-7519128B2457}"/>
               </a:ext>
             </a:extLst>
           </p:cNvPr>
@@ -4653,7 +4653,7 @@
           <p:cNvPr id="9" name="">
             <a:extLst xmlns:a="http://schemas.openxmlformats.org/drawingml/2006/main">
               <a:ext uri="{FF2B5EF4-FFF2-40B4-BE49-F238E27FC236}">
-                <a16:creationId xmlns:a16="http://schemas.microsoft.com/office/drawing/2014/main" id="{430C0CC0-E456-484E-B8E1-03DA75E20141}"/>
+                <a16:creationId xmlns:a16="http://schemas.microsoft.com/office/drawing/2014/main" id="{1F6D489C-3A99-4F12-8B22-A8064E52C15D}"/>
               </a:ext>
             </a:extLst>
           </p:cNvPr>
@@ -4774,7 +4774,7 @@
           <p:cNvPr id="10" name="">
             <a:extLst xmlns:a="http://schemas.openxmlformats.org/drawingml/2006/main">
               <a:ext uri="{FF2B5EF4-FFF2-40B4-BE49-F238E27FC236}">
-                <a16:creationId xmlns:a16="http://schemas.microsoft.com/office/drawing/2014/main" id="{2317F634-FFCF-436A-8DD4-3A839FFA2AEE}"/>
+                <a16:creationId xmlns:a16="http://schemas.microsoft.com/office/drawing/2014/main" id="{8E780686-40B9-4887-9EB0-7B4E696A7847}"/>
               </a:ext>
             </a:extLst>
           </p:cNvPr>
@@ -4807,7 +4807,7 @@
           <p:cNvPr id="11" name="">
             <a:extLst xmlns:a="http://schemas.openxmlformats.org/drawingml/2006/main">
               <a:ext uri="{FF2B5EF4-FFF2-40B4-BE49-F238E27FC236}">
-                <a16:creationId xmlns:a16="http://schemas.microsoft.com/office/drawing/2014/main" id="{249493D0-68D0-4AAE-85CA-1729CDB58FED}"/>
+                <a16:creationId xmlns:a16="http://schemas.microsoft.com/office/drawing/2014/main" id="{F5857A27-970C-43CB-B690-12A07EFEFB3D}"/>
               </a:ext>
             </a:extLst>
           </p:cNvPr>
@@ -4928,7 +4928,7 @@
           <p:cNvPr id="12" name="">
             <a:extLst xmlns:a="http://schemas.openxmlformats.org/drawingml/2006/main">
               <a:ext uri="{FF2B5EF4-FFF2-40B4-BE49-F238E27FC236}">
-                <a16:creationId xmlns:a16="http://schemas.microsoft.com/office/drawing/2014/main" id="{2A2FE053-BCC5-4DC3-8066-904DCC5BDD78}"/>
+                <a16:creationId xmlns:a16="http://schemas.microsoft.com/office/drawing/2014/main" id="{1A852FEC-A2AF-4634-94AB-20D3089651F5}"/>
               </a:ext>
             </a:extLst>
           </p:cNvPr>
@@ -5049,7 +5049,7 @@
           <p:cNvPr id="13" name="">
             <a:extLst xmlns:a="http://schemas.openxmlformats.org/drawingml/2006/main">
               <a:ext uri="{FF2B5EF4-FFF2-40B4-BE49-F238E27FC236}">
-                <a16:creationId xmlns:a16="http://schemas.microsoft.com/office/drawing/2014/main" id="{E4E142DF-6BA3-4F52-943B-D1F884A9A64B}"/>
+                <a16:creationId xmlns:a16="http://schemas.microsoft.com/office/drawing/2014/main" id="{1F3F01E8-4D64-4A25-9DD9-7388D849EF59}"/>
               </a:ext>
             </a:extLst>
           </p:cNvPr>
@@ -5170,7 +5170,7 @@
           <p:cNvPr id="14" name="">
             <a:extLst xmlns:a="http://schemas.openxmlformats.org/drawingml/2006/main">
               <a:ext uri="{FF2B5EF4-FFF2-40B4-BE49-F238E27FC236}">
-                <a16:creationId xmlns:a16="http://schemas.microsoft.com/office/drawing/2014/main" id="{D1FAB9F4-1D2A-44D8-BFC1-8147663466ED}"/>
+                <a16:creationId xmlns:a16="http://schemas.microsoft.com/office/drawing/2014/main" id="{8D25003B-34FE-44BC-99ED-34F83D3B0B2C}"/>
               </a:ext>
             </a:extLst>
           </p:cNvPr>
@@ -5203,7 +5203,7 @@
           <p:cNvPr id="15" name="">
             <a:extLst xmlns:a="http://schemas.openxmlformats.org/drawingml/2006/main">
               <a:ext uri="{FF2B5EF4-FFF2-40B4-BE49-F238E27FC236}">
-                <a16:creationId xmlns:a16="http://schemas.microsoft.com/office/drawing/2014/main" id="{9C79D926-BB55-4D50-A3FD-7FED8EA4E2EF}"/>
+                <a16:creationId xmlns:a16="http://schemas.microsoft.com/office/drawing/2014/main" id="{BB2E87FE-0653-43B1-9C8C-D68980B08172}"/>
               </a:ext>
             </a:extLst>
           </p:cNvPr>
@@ -5324,7 +5324,7 @@
           <p:cNvPr id="16" name="">
             <a:extLst xmlns:a="http://schemas.openxmlformats.org/drawingml/2006/main">
               <a:ext uri="{FF2B5EF4-FFF2-40B4-BE49-F238E27FC236}">
-                <a16:creationId xmlns:a16="http://schemas.microsoft.com/office/drawing/2014/main" id="{5FEB422F-17EC-4C39-AF8B-7FB83264A418}"/>
+                <a16:creationId xmlns:a16="http://schemas.microsoft.com/office/drawing/2014/main" id="{9FAAD8D1-004D-4A0F-8B6F-BF1BED5E8E29}"/>
               </a:ext>
             </a:extLst>
           </p:cNvPr>
@@ -5445,7 +5445,7 @@
           <p:cNvPr id="17" name="">
             <a:extLst xmlns:a="http://schemas.openxmlformats.org/drawingml/2006/main">
               <a:ext uri="{FF2B5EF4-FFF2-40B4-BE49-F238E27FC236}">
-                <a16:creationId xmlns:a16="http://schemas.microsoft.com/office/drawing/2014/main" id="{C317AC7B-F8AE-4282-A5BC-8FBB2C6713FD}"/>
+                <a16:creationId xmlns:a16="http://schemas.microsoft.com/office/drawing/2014/main" id="{F47A2FB9-2F00-4A85-B0E3-6C4FE49B1AC0}"/>
               </a:ext>
             </a:extLst>
           </p:cNvPr>
@@ -5566,7 +5566,7 @@
           <p:cNvPr id="18" name="">
             <a:extLst xmlns:a="http://schemas.openxmlformats.org/drawingml/2006/main">
               <a:ext uri="{FF2B5EF4-FFF2-40B4-BE49-F238E27FC236}">
-                <a16:creationId xmlns:a16="http://schemas.microsoft.com/office/drawing/2014/main" id="{BAE27209-F6FA-4912-9647-7FBFB6AC4DE7}"/>
+                <a16:creationId xmlns:a16="http://schemas.microsoft.com/office/drawing/2014/main" id="{0D0F85DD-57E0-4DB3-A347-D7081E53B2EA}"/>
               </a:ext>
             </a:extLst>
           </p:cNvPr>
@@ -5599,7 +5599,7 @@
           <p:cNvPr id="19" name="">
             <a:extLst xmlns:a="http://schemas.openxmlformats.org/drawingml/2006/main">
               <a:ext uri="{FF2B5EF4-FFF2-40B4-BE49-F238E27FC236}">
-                <a16:creationId xmlns:a16="http://schemas.microsoft.com/office/drawing/2014/main" id="{38AB37F4-0721-45E1-A863-4C26B73DCEAF}"/>
+                <a16:creationId xmlns:a16="http://schemas.microsoft.com/office/drawing/2014/main" id="{A7BADD61-4F1D-448B-93B0-2FF5EC3D6D28}"/>
               </a:ext>
             </a:extLst>
           </p:cNvPr>
@@ -5720,7 +5720,7 @@
           <p:cNvPr id="20" name="">
             <a:extLst xmlns:a="http://schemas.openxmlformats.org/drawingml/2006/main">
               <a:ext uri="{FF2B5EF4-FFF2-40B4-BE49-F238E27FC236}">
-                <a16:creationId xmlns:a16="http://schemas.microsoft.com/office/drawing/2014/main" id="{45AD6FBF-0172-46AA-ADFE-67932543E270}"/>
+                <a16:creationId xmlns:a16="http://schemas.microsoft.com/office/drawing/2014/main" id="{88ACF555-1984-499C-B5ED-E59D357ED903}"/>
               </a:ext>
             </a:extLst>
           </p:cNvPr>
@@ -5841,7 +5841,7 @@
           <p:cNvPr id="21" name="">
             <a:extLst xmlns:a="http://schemas.openxmlformats.org/drawingml/2006/main">
               <a:ext uri="{FF2B5EF4-FFF2-40B4-BE49-F238E27FC236}">
-                <a16:creationId xmlns:a16="http://schemas.microsoft.com/office/drawing/2014/main" id="{8D8E9B13-1BFA-4700-A428-9157BEBD0BDB}"/>
+                <a16:creationId xmlns:a16="http://schemas.microsoft.com/office/drawing/2014/main" id="{34D95F8A-28FE-4435-80FA-ABFA8274D33F}"/>
               </a:ext>
             </a:extLst>
           </p:cNvPr>
@@ -5962,7 +5962,7 @@
           <p:cNvPr id="22" name="">
             <a:extLst xmlns:a="http://schemas.openxmlformats.org/drawingml/2006/main">
               <a:ext uri="{FF2B5EF4-FFF2-40B4-BE49-F238E27FC236}">
-                <a16:creationId xmlns:a16="http://schemas.microsoft.com/office/drawing/2014/main" id="{66BD235B-2AFC-432A-94FD-6BD76E2552B1}"/>
+                <a16:creationId xmlns:a16="http://schemas.microsoft.com/office/drawing/2014/main" id="{A5375118-E023-4ECE-8CAE-A74A9C570E23}"/>
               </a:ext>
             </a:extLst>
           </p:cNvPr>
@@ -5997,7 +5997,7 @@
           <p:cNvPr id="23" name="">
             <a:extLst xmlns:a="http://schemas.openxmlformats.org/drawingml/2006/main">
               <a:ext uri="{FF2B5EF4-FFF2-40B4-BE49-F238E27FC236}">
-                <a16:creationId xmlns:a16="http://schemas.microsoft.com/office/drawing/2014/main" id="{01B82F40-408B-4F73-AA64-DFF2E0A3D281}"/>
+                <a16:creationId xmlns:a16="http://schemas.microsoft.com/office/drawing/2014/main" id="{552B8907-211C-40D7-93E1-87CE8D31E3C0}"/>
               </a:ext>
             </a:extLst>
           </p:cNvPr>
@@ -6118,7 +6118,7 @@
           <p:cNvPr id="24" name="">
             <a:extLst xmlns:a="http://schemas.openxmlformats.org/drawingml/2006/main">
               <a:ext uri="{FF2B5EF4-FFF2-40B4-BE49-F238E27FC236}">
-                <a16:creationId xmlns:a16="http://schemas.microsoft.com/office/drawing/2014/main" id="{1A13A22B-1CAA-4EEF-AE0D-6724176128C9}"/>
+                <a16:creationId xmlns:a16="http://schemas.microsoft.com/office/drawing/2014/main" id="{43F7FD1B-4B31-4816-8CB6-E06E5DED4BCD}"/>
               </a:ext>
             </a:extLst>
           </p:cNvPr>
@@ -6239,7 +6239,7 @@
           <p:cNvPr id="25" name="">
             <a:extLst xmlns:a="http://schemas.openxmlformats.org/drawingml/2006/main">
               <a:ext uri="{FF2B5EF4-FFF2-40B4-BE49-F238E27FC236}">
-                <a16:creationId xmlns:a16="http://schemas.microsoft.com/office/drawing/2014/main" id="{C2CC9BFF-8A66-4813-9290-3766B35952D0}"/>
+                <a16:creationId xmlns:a16="http://schemas.microsoft.com/office/drawing/2014/main" id="{06B9969D-277F-4932-AA28-40AFB1749022}"/>
               </a:ext>
             </a:extLst>
           </p:cNvPr>
@@ -6358,7 +6358,7 @@
     </p:spTree>
     <p:extLst>
       <p:ext uri="{BB962C8B-B14F-4D97-AF65-F5344CB8AC3E}">
-        <p14:creationId xmlns:p14="http://schemas.microsoft.com/office/powerpoint/2010/main" val="1119168199"/>
+        <p14:creationId xmlns:p14="http://schemas.microsoft.com/office/powerpoint/2010/main" val="808396470"/>
       </p:ext>
     </p:extLst>
   </p:cSld>
@@ -6389,7 +6389,7 @@
           <p:cNvPr id="11" name="">
             <a:extLst xmlns:a="http://schemas.openxmlformats.org/drawingml/2006/main">
               <a:ext uri="{FF2B5EF4-FFF2-40B4-BE49-F238E27FC236}">
-                <a16:creationId xmlns:a16="http://schemas.microsoft.com/office/drawing/2014/main" id="{AAE017A6-83C5-4205-B75F-B7CCA9A4F1F6}"/>
+                <a16:creationId xmlns:a16="http://schemas.microsoft.com/office/drawing/2014/main" id="{A318B0E9-22ED-4D8A-B9B7-694E14E571F7}"/>
               </a:ext>
             </a:extLst>
           </p:cNvPr>
@@ -6510,7 +6510,7 @@
           <p:cNvPr id="2" name="">
             <a:extLst xmlns:a="http://schemas.openxmlformats.org/drawingml/2006/main">
               <a:ext uri="{FF2B5EF4-FFF2-40B4-BE49-F238E27FC236}">
-                <a16:creationId xmlns:a16="http://schemas.microsoft.com/office/drawing/2014/main" id="{1F08BAE4-1EB1-4F65-96B4-0827A54DD291}"/>
+                <a16:creationId xmlns:a16="http://schemas.microsoft.com/office/drawing/2014/main" id="{3E329F72-79E7-4883-8BD4-62422CB18C0A}"/>
               </a:ext>
             </a:extLst>
           </p:cNvPr>
@@ -6631,7 +6631,7 @@
           <p:cNvPr id="3" name="">
             <a:extLst xmlns:a="http://schemas.openxmlformats.org/drawingml/2006/main">
               <a:ext uri="{FF2B5EF4-FFF2-40B4-BE49-F238E27FC236}">
-                <a16:creationId xmlns:a16="http://schemas.microsoft.com/office/drawing/2014/main" id="{51635256-3A77-4480-873C-CF1FFE3F0513}"/>
+                <a16:creationId xmlns:a16="http://schemas.microsoft.com/office/drawing/2014/main" id="{48FC475F-F290-4ACB-BB40-4B1569EEA6B9}"/>
               </a:ext>
             </a:extLst>
           </p:cNvPr>
@@ -6662,7 +6662,7 @@
           <p:cNvPr id="4" name="">
             <a:extLst xmlns:a="http://schemas.openxmlformats.org/drawingml/2006/main">
               <a:ext uri="{FF2B5EF4-FFF2-40B4-BE49-F238E27FC236}">
-                <a16:creationId xmlns:a16="http://schemas.microsoft.com/office/drawing/2014/main" id="{5F4E6D3E-DC5C-4F96-ACC6-410DE06E609F}"/>
+                <a16:creationId xmlns:a16="http://schemas.microsoft.com/office/drawing/2014/main" id="{877FB591-B1EC-442D-B42B-EE76F8C876E4}"/>
               </a:ext>
             </a:extLst>
           </p:cNvPr>
@@ -6783,7 +6783,7 @@
           <p:cNvPr id="5" name="">
             <a:extLst xmlns:a="http://schemas.openxmlformats.org/drawingml/2006/main">
               <a:ext uri="{FF2B5EF4-FFF2-40B4-BE49-F238E27FC236}">
-                <a16:creationId xmlns:a16="http://schemas.microsoft.com/office/drawing/2014/main" id="{6636B854-CEB0-4067-B3EE-17BF7F078903}"/>
+                <a16:creationId xmlns:a16="http://schemas.microsoft.com/office/drawing/2014/main" id="{6A577683-7A0E-447F-944B-CD6F3E976BCE}"/>
               </a:ext>
             </a:extLst>
           </p:cNvPr>
@@ -6818,7 +6818,7 @@
           <p:cNvPr id="6" name="">
             <a:extLst xmlns:a="http://schemas.openxmlformats.org/drawingml/2006/main">
               <a:ext uri="{FF2B5EF4-FFF2-40B4-BE49-F238E27FC236}">
-                <a16:creationId xmlns:a16="http://schemas.microsoft.com/office/drawing/2014/main" id="{025BF5F6-7495-41CF-B323-A6251ECE66A5}"/>
+                <a16:creationId xmlns:a16="http://schemas.microsoft.com/office/drawing/2014/main" id="{208D16EB-EC6E-43DD-A6B9-91D561B1B84A}"/>
               </a:ext>
             </a:extLst>
           </p:cNvPr>
@@ -6828,7 +6828,7 @@
           <p:nvPr/>
         </p:nvPicPr>
         <p:blipFill>
-          <a:blip xmlns:r="http://schemas.openxmlformats.org/officeDocument/2006/relationships" xmlns:a="http://schemas.openxmlformats.org/drawingml/2006/main" r:embed="R64e57f5180214e54"/>
+          <a:blip xmlns:r="http://schemas.openxmlformats.org/officeDocument/2006/relationships" xmlns:a="http://schemas.openxmlformats.org/drawingml/2006/main" r:embed="R8b9b1b6e35a64b0e"/>
           <a:srcRect xmlns:a="http://schemas.openxmlformats.org/drawingml/2006/main" l="0" t="1000" r="0" b="39000"/>
           <a:stretch xmlns:a="http://schemas.openxmlformats.org/drawingml/2006/main"/>
         </p:blipFill>
@@ -6849,7 +6849,7 @@
           <p:cNvPr id="7" name="">
             <a:extLst xmlns:a="http://schemas.openxmlformats.org/drawingml/2006/main">
               <a:ext uri="{FF2B5EF4-FFF2-40B4-BE49-F238E27FC236}">
-                <a16:creationId xmlns:a16="http://schemas.microsoft.com/office/drawing/2014/main" id="{9F8A199C-9936-43F0-AD67-1293034A5216}"/>
+                <a16:creationId xmlns:a16="http://schemas.microsoft.com/office/drawing/2014/main" id="{4F9AB939-5B64-487A-8F77-BB3534034450}"/>
               </a:ext>
             </a:extLst>
           </p:cNvPr>
@@ -6884,7 +6884,7 @@
           <p:cNvPr id="8" name="">
             <a:extLst xmlns:a="http://schemas.openxmlformats.org/drawingml/2006/main">
               <a:ext uri="{FF2B5EF4-FFF2-40B4-BE49-F238E27FC236}">
-                <a16:creationId xmlns:a16="http://schemas.microsoft.com/office/drawing/2014/main" id="{EE3C7EF5-2202-42ED-B52E-2E35CF1B036A}"/>
+                <a16:creationId xmlns:a16="http://schemas.microsoft.com/office/drawing/2014/main" id="{5A4A570C-490A-449E-BB1E-30008570FC7D}"/>
               </a:ext>
             </a:extLst>
           </p:cNvPr>
@@ -7005,7 +7005,7 @@
           <p:cNvPr id="9" name="">
             <a:extLst xmlns:a="http://schemas.openxmlformats.org/drawingml/2006/main">
               <a:ext uri="{FF2B5EF4-FFF2-40B4-BE49-F238E27FC236}">
-                <a16:creationId xmlns:a16="http://schemas.microsoft.com/office/drawing/2014/main" id="{905B0E88-ECB0-4895-AE8F-60DB64CDC34C}"/>
+                <a16:creationId xmlns:a16="http://schemas.microsoft.com/office/drawing/2014/main" id="{A023398A-FF8D-478B-9C9B-579A9E0D735B}"/>
               </a:ext>
             </a:extLst>
           </p:cNvPr>
@@ -7126,7 +7126,7 @@
           <p:cNvPr id="10" name="">
             <a:extLst xmlns:a="http://schemas.openxmlformats.org/drawingml/2006/main">
               <a:ext uri="{FF2B5EF4-FFF2-40B4-BE49-F238E27FC236}">
-                <a16:creationId xmlns:a16="http://schemas.microsoft.com/office/drawing/2014/main" id="{0B3E2D9C-E3B2-4A79-9627-529E2D4D9F8F}"/>
+                <a16:creationId xmlns:a16="http://schemas.microsoft.com/office/drawing/2014/main" id="{AA6016DD-CAFB-4FB3-9C40-EB397D778BE7}"/>
               </a:ext>
             </a:extLst>
           </p:cNvPr>
@@ -7245,7 +7245,7 @@
     </p:spTree>
     <p:extLst>
       <p:ext uri="{BB962C8B-B14F-4D97-AF65-F5344CB8AC3E}">
-        <p14:creationId xmlns:p14="http://schemas.microsoft.com/office/powerpoint/2010/main" val="232342565"/>
+        <p14:creationId xmlns:p14="http://schemas.microsoft.com/office/powerpoint/2010/main" val="1736033857"/>
       </p:ext>
     </p:extLst>
   </p:cSld>
@@ -7276,7 +7276,7 @@
           <p:cNvPr id="36" name="">
             <a:extLst xmlns:a="http://schemas.openxmlformats.org/drawingml/2006/main">
               <a:ext uri="{FF2B5EF4-FFF2-40B4-BE49-F238E27FC236}">
-                <a16:creationId xmlns:a16="http://schemas.microsoft.com/office/drawing/2014/main" id="{08AA74C9-011B-46D8-B432-2C34936F2AC5}"/>
+                <a16:creationId xmlns:a16="http://schemas.microsoft.com/office/drawing/2014/main" id="{941D1F20-1324-47D2-8BBE-F089208DEC8C}"/>
               </a:ext>
             </a:extLst>
           </p:cNvPr>
@@ -7397,7 +7397,7 @@
           <p:cNvPr id="2" name="">
             <a:extLst xmlns:a="http://schemas.openxmlformats.org/drawingml/2006/main">
               <a:ext uri="{FF2B5EF4-FFF2-40B4-BE49-F238E27FC236}">
-                <a16:creationId xmlns:a16="http://schemas.microsoft.com/office/drawing/2014/main" id="{2B7A05FF-1793-4A5B-99DF-C9964DBCDE94}"/>
+                <a16:creationId xmlns:a16="http://schemas.microsoft.com/office/drawing/2014/main" id="{B021D89D-9FAE-4264-880B-CCE2015310F6}"/>
               </a:ext>
             </a:extLst>
           </p:cNvPr>
@@ -7518,7 +7518,7 @@
           <p:cNvPr id="3" name="">
             <a:extLst xmlns:a="http://schemas.openxmlformats.org/drawingml/2006/main">
               <a:ext uri="{FF2B5EF4-FFF2-40B4-BE49-F238E27FC236}">
-                <a16:creationId xmlns:a16="http://schemas.microsoft.com/office/drawing/2014/main" id="{080D05F7-E37D-4736-91EE-8E305A5E971D}"/>
+                <a16:creationId xmlns:a16="http://schemas.microsoft.com/office/drawing/2014/main" id="{FA9F0026-E6F3-40C5-B4DF-F719B2966704}"/>
               </a:ext>
             </a:extLst>
           </p:cNvPr>
@@ -7549,7 +7549,7 @@
           <p:cNvPr id="4" name="">
             <a:extLst xmlns:a="http://schemas.openxmlformats.org/drawingml/2006/main">
               <a:ext uri="{FF2B5EF4-FFF2-40B4-BE49-F238E27FC236}">
-                <a16:creationId xmlns:a16="http://schemas.microsoft.com/office/drawing/2014/main" id="{99F256E0-FCE7-49A5-A695-58E9831452A3}"/>
+                <a16:creationId xmlns:a16="http://schemas.microsoft.com/office/drawing/2014/main" id="{9274622E-EE43-4C38-B82C-500CB0D44696}"/>
               </a:ext>
             </a:extLst>
           </p:cNvPr>
@@ -7670,7 +7670,7 @@
           <p:cNvPr id="5" name="">
             <a:extLst xmlns:a="http://schemas.openxmlformats.org/drawingml/2006/main">
               <a:ext uri="{FF2B5EF4-FFF2-40B4-BE49-F238E27FC236}">
-                <a16:creationId xmlns:a16="http://schemas.microsoft.com/office/drawing/2014/main" id="{2DBD17B8-123B-4F68-A876-3D17DA3C0942}"/>
+                <a16:creationId xmlns:a16="http://schemas.microsoft.com/office/drawing/2014/main" id="{AAE3BDAE-0FF7-42A3-92E7-C4BE174C82D6}"/>
               </a:ext>
             </a:extLst>
           </p:cNvPr>
@@ -7705,7 +7705,7 @@
           <p:cNvPr id="6" name="">
             <a:extLst xmlns:a="http://schemas.openxmlformats.org/drawingml/2006/main">
               <a:ext uri="{FF2B5EF4-FFF2-40B4-BE49-F238E27FC236}">
-                <a16:creationId xmlns:a16="http://schemas.microsoft.com/office/drawing/2014/main" id="{19D197FD-F19F-4973-B343-FBED50D45A9B}"/>
+                <a16:creationId xmlns:a16="http://schemas.microsoft.com/office/drawing/2014/main" id="{2C4D2827-F8E8-4F9B-8D21-B2215822DF19}"/>
               </a:ext>
             </a:extLst>
           </p:cNvPr>
@@ -7826,7 +7826,7 @@
           <p:cNvPr id="7" name="">
             <a:extLst xmlns:a="http://schemas.openxmlformats.org/drawingml/2006/main">
               <a:ext uri="{FF2B5EF4-FFF2-40B4-BE49-F238E27FC236}">
-                <a16:creationId xmlns:a16="http://schemas.microsoft.com/office/drawing/2014/main" id="{B89F7193-101F-40F2-9C6F-CCC93AF97437}"/>
+                <a16:creationId xmlns:a16="http://schemas.microsoft.com/office/drawing/2014/main" id="{36E0CF80-BB76-4023-9597-787643D52572}"/>
               </a:ext>
             </a:extLst>
           </p:cNvPr>
@@ -7947,7 +7947,7 @@
           <p:cNvPr id="8" name="">
             <a:extLst xmlns:a="http://schemas.openxmlformats.org/drawingml/2006/main">
               <a:ext uri="{FF2B5EF4-FFF2-40B4-BE49-F238E27FC236}">
-                <a16:creationId xmlns:a16="http://schemas.microsoft.com/office/drawing/2014/main" id="{F8455E93-7034-445B-9307-4F4C5C6A0B4B}"/>
+                <a16:creationId xmlns:a16="http://schemas.microsoft.com/office/drawing/2014/main" id="{6AA0C12A-9A99-4FDB-BE52-8D8919658A99}"/>
               </a:ext>
             </a:extLst>
           </p:cNvPr>
@@ -8068,7 +8068,7 @@
           <p:cNvPr id="9" name="">
             <a:extLst xmlns:a="http://schemas.openxmlformats.org/drawingml/2006/main">
               <a:ext uri="{FF2B5EF4-FFF2-40B4-BE49-F238E27FC236}">
-                <a16:creationId xmlns:a16="http://schemas.microsoft.com/office/drawing/2014/main" id="{657E0DBB-1D85-495C-A7EF-047A5BBBE2D2}"/>
+                <a16:creationId xmlns:a16="http://schemas.microsoft.com/office/drawing/2014/main" id="{AE27DB20-DA95-49DE-9AA9-41C2DA740468}"/>
               </a:ext>
             </a:extLst>
           </p:cNvPr>
@@ -8099,7 +8099,7 @@
           <p:cNvPr id="10" name="">
             <a:extLst xmlns:a="http://schemas.openxmlformats.org/drawingml/2006/main">
               <a:ext uri="{FF2B5EF4-FFF2-40B4-BE49-F238E27FC236}">
-                <a16:creationId xmlns:a16="http://schemas.microsoft.com/office/drawing/2014/main" id="{B359C3BA-BF67-4D2A-BEA7-88456957532F}"/>
+                <a16:creationId xmlns:a16="http://schemas.microsoft.com/office/drawing/2014/main" id="{78A3D883-B173-4212-A8B7-6E32493013CF}"/>
               </a:ext>
             </a:extLst>
           </p:cNvPr>
@@ -8134,7 +8134,7 @@
           <p:cNvPr id="11" name="">
             <a:extLst xmlns:a="http://schemas.openxmlformats.org/drawingml/2006/main">
               <a:ext uri="{FF2B5EF4-FFF2-40B4-BE49-F238E27FC236}">
-                <a16:creationId xmlns:a16="http://schemas.microsoft.com/office/drawing/2014/main" id="{99120012-95D7-4B09-932C-1E4A00DF9C78}"/>
+                <a16:creationId xmlns:a16="http://schemas.microsoft.com/office/drawing/2014/main" id="{B8115CD1-150C-42B5-AE62-63F9BCB4C454}"/>
               </a:ext>
             </a:extLst>
           </p:cNvPr>
@@ -8255,7 +8255,7 @@
           <p:cNvPr id="12" name="">
             <a:extLst xmlns:a="http://schemas.openxmlformats.org/drawingml/2006/main">
               <a:ext uri="{FF2B5EF4-FFF2-40B4-BE49-F238E27FC236}">
-                <a16:creationId xmlns:a16="http://schemas.microsoft.com/office/drawing/2014/main" id="{2D30EC7A-FE6E-4A27-AC87-F35147A71C99}"/>
+                <a16:creationId xmlns:a16="http://schemas.microsoft.com/office/drawing/2014/main" id="{1F181411-D73F-4957-A408-429ED9766AFB}"/>
               </a:ext>
             </a:extLst>
           </p:cNvPr>
@@ -8376,7 +8376,7 @@
           <p:cNvPr id="13" name="">
             <a:extLst xmlns:a="http://schemas.openxmlformats.org/drawingml/2006/main">
               <a:ext uri="{FF2B5EF4-FFF2-40B4-BE49-F238E27FC236}">
-                <a16:creationId xmlns:a16="http://schemas.microsoft.com/office/drawing/2014/main" id="{BEB7AD14-4FE5-4F52-B4D2-F38C9D1D61F0}"/>
+                <a16:creationId xmlns:a16="http://schemas.microsoft.com/office/drawing/2014/main" id="{19DDA7E2-7954-4246-9792-B0728D5BA4C0}"/>
               </a:ext>
             </a:extLst>
           </p:cNvPr>
@@ -8497,7 +8497,7 @@
           <p:cNvPr id="14" name="">
             <a:extLst xmlns:a="http://schemas.openxmlformats.org/drawingml/2006/main">
               <a:ext uri="{FF2B5EF4-FFF2-40B4-BE49-F238E27FC236}">
-                <a16:creationId xmlns:a16="http://schemas.microsoft.com/office/drawing/2014/main" id="{85744C23-330E-4BC3-BED7-EBCC0AB8F11E}"/>
+                <a16:creationId xmlns:a16="http://schemas.microsoft.com/office/drawing/2014/main" id="{73C43D98-210F-409F-8F91-8EDCF160F65C}"/>
               </a:ext>
             </a:extLst>
           </p:cNvPr>
@@ -8528,7 +8528,7 @@
           <p:cNvPr id="15" name="">
             <a:extLst xmlns:a="http://schemas.openxmlformats.org/drawingml/2006/main">
               <a:ext uri="{FF2B5EF4-FFF2-40B4-BE49-F238E27FC236}">
-                <a16:creationId xmlns:a16="http://schemas.microsoft.com/office/drawing/2014/main" id="{F804ED72-22E5-43E5-8E1C-1618D93314C1}"/>
+                <a16:creationId xmlns:a16="http://schemas.microsoft.com/office/drawing/2014/main" id="{2AC57B47-1719-44FE-973C-6845F8C8A1FF}"/>
               </a:ext>
             </a:extLst>
           </p:cNvPr>
@@ -8563,7 +8563,7 @@
           <p:cNvPr id="16" name="">
             <a:extLst xmlns:a="http://schemas.openxmlformats.org/drawingml/2006/main">
               <a:ext uri="{FF2B5EF4-FFF2-40B4-BE49-F238E27FC236}">
-                <a16:creationId xmlns:a16="http://schemas.microsoft.com/office/drawing/2014/main" id="{573096D9-96FA-4BD3-A9AE-38BEF47FC5B3}"/>
+                <a16:creationId xmlns:a16="http://schemas.microsoft.com/office/drawing/2014/main" id="{B3805C13-0A1F-458C-BFB7-14504E52813E}"/>
               </a:ext>
             </a:extLst>
           </p:cNvPr>
@@ -8684,7 +8684,7 @@
           <p:cNvPr id="17" name="">
             <a:extLst xmlns:a="http://schemas.openxmlformats.org/drawingml/2006/main">
               <a:ext uri="{FF2B5EF4-FFF2-40B4-BE49-F238E27FC236}">
-                <a16:creationId xmlns:a16="http://schemas.microsoft.com/office/drawing/2014/main" id="{243520E0-9399-49D6-9B5F-F8F3D8AD816F}"/>
+                <a16:creationId xmlns:a16="http://schemas.microsoft.com/office/drawing/2014/main" id="{0F382212-4BB1-4DEA-9B27-06AD82AC85AD}"/>
               </a:ext>
             </a:extLst>
           </p:cNvPr>
@@ -8805,7 +8805,7 @@
           <p:cNvPr id="18" name="">
             <a:extLst xmlns:a="http://schemas.openxmlformats.org/drawingml/2006/main">
               <a:ext uri="{FF2B5EF4-FFF2-40B4-BE49-F238E27FC236}">
-                <a16:creationId xmlns:a16="http://schemas.microsoft.com/office/drawing/2014/main" id="{23A29578-B820-4E7E-8D9B-F144B98F641E}"/>
+                <a16:creationId xmlns:a16="http://schemas.microsoft.com/office/drawing/2014/main" id="{60BA1DB6-1B13-441C-8AA0-B2624AA8B4FD}"/>
               </a:ext>
             </a:extLst>
           </p:cNvPr>
@@ -8926,7 +8926,7 @@
           <p:cNvPr id="19" name="">
             <a:extLst xmlns:a="http://schemas.openxmlformats.org/drawingml/2006/main">
               <a:ext uri="{FF2B5EF4-FFF2-40B4-BE49-F238E27FC236}">
-                <a16:creationId xmlns:a16="http://schemas.microsoft.com/office/drawing/2014/main" id="{01D4A94A-62ED-44E0-B983-8B21E48C378E}"/>
+                <a16:creationId xmlns:a16="http://schemas.microsoft.com/office/drawing/2014/main" id="{67FBB396-C0F5-44BC-8D65-942A12102C5E}"/>
               </a:ext>
             </a:extLst>
           </p:cNvPr>
@@ -8957,7 +8957,7 @@
           <p:cNvPr id="20" name="">
             <a:extLst xmlns:a="http://schemas.openxmlformats.org/drawingml/2006/main">
               <a:ext uri="{FF2B5EF4-FFF2-40B4-BE49-F238E27FC236}">
-                <a16:creationId xmlns:a16="http://schemas.microsoft.com/office/drawing/2014/main" id="{3C75DA78-F071-492A-A4EB-7BAB67D1CAD1}"/>
+                <a16:creationId xmlns:a16="http://schemas.microsoft.com/office/drawing/2014/main" id="{24BEB348-D0C8-459A-A213-7E04280F410E}"/>
               </a:ext>
             </a:extLst>
           </p:cNvPr>
@@ -8992,7 +8992,7 @@
           <p:cNvPr id="21" name="">
             <a:extLst xmlns:a="http://schemas.openxmlformats.org/drawingml/2006/main">
               <a:ext uri="{FF2B5EF4-FFF2-40B4-BE49-F238E27FC236}">
-                <a16:creationId xmlns:a16="http://schemas.microsoft.com/office/drawing/2014/main" id="{57DC143D-4A20-4466-8FA6-BB2291CCAB6F}"/>
+                <a16:creationId xmlns:a16="http://schemas.microsoft.com/office/drawing/2014/main" id="{26A9CCCB-8BDB-4E33-8C0E-1A5B157A58E7}"/>
               </a:ext>
             </a:extLst>
           </p:cNvPr>
@@ -9113,7 +9113,7 @@
           <p:cNvPr id="22" name="">
             <a:extLst xmlns:a="http://schemas.openxmlformats.org/drawingml/2006/main">
               <a:ext uri="{FF2B5EF4-FFF2-40B4-BE49-F238E27FC236}">
-                <a16:creationId xmlns:a16="http://schemas.microsoft.com/office/drawing/2014/main" id="{88412DE7-46A4-427B-A5B2-57436B4A9934}"/>
+                <a16:creationId xmlns:a16="http://schemas.microsoft.com/office/drawing/2014/main" id="{33878DB9-907E-47A3-9F58-C1D090211203}"/>
               </a:ext>
             </a:extLst>
           </p:cNvPr>
@@ -9234,7 +9234,7 @@
           <p:cNvPr id="23" name="">
             <a:extLst xmlns:a="http://schemas.openxmlformats.org/drawingml/2006/main">
               <a:ext uri="{FF2B5EF4-FFF2-40B4-BE49-F238E27FC236}">
-                <a16:creationId xmlns:a16="http://schemas.microsoft.com/office/drawing/2014/main" id="{F2588EE6-711B-4642-BC2D-47BD1A8F44D1}"/>
+                <a16:creationId xmlns:a16="http://schemas.microsoft.com/office/drawing/2014/main" id="{D6F7397D-BDEA-4C5F-B1DC-30D509CC7BBD}"/>
               </a:ext>
             </a:extLst>
           </p:cNvPr>
@@ -9355,7 +9355,7 @@
           <p:cNvPr id="24" name="">
             <a:extLst xmlns:a="http://schemas.openxmlformats.org/drawingml/2006/main">
               <a:ext uri="{FF2B5EF4-FFF2-40B4-BE49-F238E27FC236}">
-                <a16:creationId xmlns:a16="http://schemas.microsoft.com/office/drawing/2014/main" id="{B870461A-ACD1-488C-8518-95572D233694}"/>
+                <a16:creationId xmlns:a16="http://schemas.microsoft.com/office/drawing/2014/main" id="{27F6F19F-48AD-473C-AA16-3830E10EE90C}"/>
               </a:ext>
             </a:extLst>
           </p:cNvPr>
@@ -9390,7 +9390,7 @@
           <p:cNvPr id="25" name="">
             <a:extLst xmlns:a="http://schemas.openxmlformats.org/drawingml/2006/main">
               <a:ext uri="{FF2B5EF4-FFF2-40B4-BE49-F238E27FC236}">
-                <a16:creationId xmlns:a16="http://schemas.microsoft.com/office/drawing/2014/main" id="{D7B3D971-41E1-43EB-A81E-32B20A547C7F}"/>
+                <a16:creationId xmlns:a16="http://schemas.microsoft.com/office/drawing/2014/main" id="{7D831140-8CF6-42AF-9EA2-6A51BF2B0EBA}"/>
               </a:ext>
             </a:extLst>
           </p:cNvPr>
@@ -9400,7 +9400,7 @@
           <p:nvPr/>
         </p:nvPicPr>
         <p:blipFill>
-          <a:blip xmlns:r="http://schemas.openxmlformats.org/officeDocument/2006/relationships" xmlns:a="http://schemas.openxmlformats.org/drawingml/2006/main" r:embed="R3ba2293677b0443e"/>
+          <a:blip xmlns:r="http://schemas.openxmlformats.org/officeDocument/2006/relationships" xmlns:a="http://schemas.openxmlformats.org/drawingml/2006/main" r:embed="Rc2b384b30de04035"/>
           <a:srcRect xmlns:a="http://schemas.openxmlformats.org/drawingml/2006/main" l="42000" t="3000" r="0" b="6000"/>
           <a:stretch xmlns:a="http://schemas.openxmlformats.org/drawingml/2006/main"/>
         </p:blipFill>
@@ -9421,7 +9421,7 @@
           <p:cNvPr id="26" name="">
             <a:extLst xmlns:a="http://schemas.openxmlformats.org/drawingml/2006/main">
               <a:ext uri="{FF2B5EF4-FFF2-40B4-BE49-F238E27FC236}">
-                <a16:creationId xmlns:a16="http://schemas.microsoft.com/office/drawing/2014/main" id="{4AF3024F-F6E2-462C-ABA5-C9F667C9D507}"/>
+                <a16:creationId xmlns:a16="http://schemas.microsoft.com/office/drawing/2014/main" id="{12F27969-C06D-4658-AB9A-21CD10BD01A5}"/>
               </a:ext>
             </a:extLst>
           </p:cNvPr>
@@ -9456,7 +9456,7 @@
           <p:cNvPr id="27" name="">
             <a:extLst xmlns:a="http://schemas.openxmlformats.org/drawingml/2006/main">
               <a:ext uri="{FF2B5EF4-FFF2-40B4-BE49-F238E27FC236}">
-                <a16:creationId xmlns:a16="http://schemas.microsoft.com/office/drawing/2014/main" id="{6D120E8C-1EBC-49CB-B91F-801E1054420C}"/>
+                <a16:creationId xmlns:a16="http://schemas.microsoft.com/office/drawing/2014/main" id="{41BBE538-C5BF-4F93-96FC-67F9421F5721}"/>
               </a:ext>
             </a:extLst>
           </p:cNvPr>
@@ -9577,7 +9577,7 @@
           <p:cNvPr id="28" name="">
             <a:extLst xmlns:a="http://schemas.openxmlformats.org/drawingml/2006/main">
               <a:ext uri="{FF2B5EF4-FFF2-40B4-BE49-F238E27FC236}">
-                <a16:creationId xmlns:a16="http://schemas.microsoft.com/office/drawing/2014/main" id="{F7CAD6A2-C37D-4488-A085-85EB2213C419}"/>
+                <a16:creationId xmlns:a16="http://schemas.microsoft.com/office/drawing/2014/main" id="{05130925-67CA-40C6-96AD-3CC602ECCEFA}"/>
               </a:ext>
             </a:extLst>
           </p:cNvPr>
@@ -9608,7 +9608,7 @@
           <p:cNvPr id="29" name="">
             <a:extLst xmlns:a="http://schemas.openxmlformats.org/drawingml/2006/main">
               <a:ext uri="{FF2B5EF4-FFF2-40B4-BE49-F238E27FC236}">
-                <a16:creationId xmlns:a16="http://schemas.microsoft.com/office/drawing/2014/main" id="{CB7AAA44-8051-4FAF-9727-D7CEE4975F88}"/>
+                <a16:creationId xmlns:a16="http://schemas.microsoft.com/office/drawing/2014/main" id="{A2472BCC-E306-4896-9D9D-33F8DCB9527B}"/>
               </a:ext>
             </a:extLst>
           </p:cNvPr>
@@ -9729,7 +9729,7 @@
           <p:cNvPr id="30" name="">
             <a:extLst xmlns:a="http://schemas.openxmlformats.org/drawingml/2006/main">
               <a:ext uri="{FF2B5EF4-FFF2-40B4-BE49-F238E27FC236}">
-                <a16:creationId xmlns:a16="http://schemas.microsoft.com/office/drawing/2014/main" id="{6B838A1E-11E5-4BB4-91E3-8A364D6A070A}"/>
+                <a16:creationId xmlns:a16="http://schemas.microsoft.com/office/drawing/2014/main" id="{DF6AE8EF-C3BA-4FFE-BB99-2D6CD74B864C}"/>
               </a:ext>
             </a:extLst>
           </p:cNvPr>
@@ -9760,7 +9760,7 @@
           <p:cNvPr id="31" name="">
             <a:extLst xmlns:a="http://schemas.openxmlformats.org/drawingml/2006/main">
               <a:ext uri="{FF2B5EF4-FFF2-40B4-BE49-F238E27FC236}">
-                <a16:creationId xmlns:a16="http://schemas.microsoft.com/office/drawing/2014/main" id="{CFCD02BD-C902-4945-BF8D-8215B329055D}"/>
+                <a16:creationId xmlns:a16="http://schemas.microsoft.com/office/drawing/2014/main" id="{15306012-16DB-446A-AFCB-BBD59D777C62}"/>
               </a:ext>
             </a:extLst>
           </p:cNvPr>
@@ -9881,7 +9881,7 @@
           <p:cNvPr id="32" name="">
             <a:extLst xmlns:a="http://schemas.openxmlformats.org/drawingml/2006/main">
               <a:ext uri="{FF2B5EF4-FFF2-40B4-BE49-F238E27FC236}">
-                <a16:creationId xmlns:a16="http://schemas.microsoft.com/office/drawing/2014/main" id="{BDFDE7C7-351C-4A00-9D19-80E32D983E8B}"/>
+                <a16:creationId xmlns:a16="http://schemas.microsoft.com/office/drawing/2014/main" id="{F6DC05B9-E5E0-4734-9721-649AB88D15C2}"/>
               </a:ext>
             </a:extLst>
           </p:cNvPr>
@@ -9912,7 +9912,7 @@
           <p:cNvPr id="33" name="">
             <a:extLst xmlns:a="http://schemas.openxmlformats.org/drawingml/2006/main">
               <a:ext uri="{FF2B5EF4-FFF2-40B4-BE49-F238E27FC236}">
-                <a16:creationId xmlns:a16="http://schemas.microsoft.com/office/drawing/2014/main" id="{ADBEE47E-870E-42C2-9E2D-0CA4F64D9DBE}"/>
+                <a16:creationId xmlns:a16="http://schemas.microsoft.com/office/drawing/2014/main" id="{A3CB6DB1-2EBE-4758-AAA9-A041022B556D}"/>
               </a:ext>
             </a:extLst>
           </p:cNvPr>
@@ -10033,7 +10033,7 @@
           <p:cNvPr id="34" name="">
             <a:extLst xmlns:a="http://schemas.openxmlformats.org/drawingml/2006/main">
               <a:ext uri="{FF2B5EF4-FFF2-40B4-BE49-F238E27FC236}">
-                <a16:creationId xmlns:a16="http://schemas.microsoft.com/office/drawing/2014/main" id="{A76A3D2C-2087-44F6-BFAE-0A6D5F4D9FEB}"/>
+                <a16:creationId xmlns:a16="http://schemas.microsoft.com/office/drawing/2014/main" id="{82BE4B9D-1370-4CFC-A47F-19CB1B4EA559}"/>
               </a:ext>
             </a:extLst>
           </p:cNvPr>
@@ -10154,7 +10154,7 @@
           <p:cNvPr id="35" name="">
             <a:extLst xmlns:a="http://schemas.openxmlformats.org/drawingml/2006/main">
               <a:ext uri="{FF2B5EF4-FFF2-40B4-BE49-F238E27FC236}">
-                <a16:creationId xmlns:a16="http://schemas.microsoft.com/office/drawing/2014/main" id="{00CB4A0B-B509-47FB-8A06-7DC41C955FA4}"/>
+                <a16:creationId xmlns:a16="http://schemas.microsoft.com/office/drawing/2014/main" id="{52D9E7AD-9CF5-4A6E-8EBF-B88E13CB3738}"/>
               </a:ext>
             </a:extLst>
           </p:cNvPr>
@@ -10273,7 +10273,7 @@
     </p:spTree>
     <p:extLst>
       <p:ext uri="{BB962C8B-B14F-4D97-AF65-F5344CB8AC3E}">
-        <p14:creationId xmlns:p14="http://schemas.microsoft.com/office/powerpoint/2010/main" val="1580697121"/>
+        <p14:creationId xmlns:p14="http://schemas.microsoft.com/office/powerpoint/2010/main" val="450097050"/>
       </p:ext>
     </p:extLst>
   </p:cSld>
@@ -10304,7 +10304,7 @@
           <p:cNvPr id="38" name="">
             <a:extLst xmlns:a="http://schemas.openxmlformats.org/drawingml/2006/main">
               <a:ext uri="{FF2B5EF4-FFF2-40B4-BE49-F238E27FC236}">
-                <a16:creationId xmlns:a16="http://schemas.microsoft.com/office/drawing/2014/main" id="{0E1295A3-5191-400E-8606-D99748FD87FD}"/>
+                <a16:creationId xmlns:a16="http://schemas.microsoft.com/office/drawing/2014/main" id="{7F97E445-3CA2-4766-A339-6B8EC88D7571}"/>
               </a:ext>
             </a:extLst>
           </p:cNvPr>
@@ -10425,7 +10425,7 @@
           <p:cNvPr id="2" name="">
             <a:extLst xmlns:a="http://schemas.openxmlformats.org/drawingml/2006/main">
               <a:ext uri="{FF2B5EF4-FFF2-40B4-BE49-F238E27FC236}">
-                <a16:creationId xmlns:a16="http://schemas.microsoft.com/office/drawing/2014/main" id="{1C54557E-B864-48EA-A749-B0A8DFCD0912}"/>
+                <a16:creationId xmlns:a16="http://schemas.microsoft.com/office/drawing/2014/main" id="{51EFA9CF-AB1F-416F-9F72-C8235C8234FC}"/>
               </a:ext>
             </a:extLst>
           </p:cNvPr>
@@ -10546,7 +10546,7 @@
           <p:cNvPr id="3" name="">
             <a:extLst xmlns:a="http://schemas.openxmlformats.org/drawingml/2006/main">
               <a:ext uri="{FF2B5EF4-FFF2-40B4-BE49-F238E27FC236}">
-                <a16:creationId xmlns:a16="http://schemas.microsoft.com/office/drawing/2014/main" id="{B131A7A1-B033-4274-B42F-835FB7746A8B}"/>
+                <a16:creationId xmlns:a16="http://schemas.microsoft.com/office/drawing/2014/main" id="{9C0A8903-8B0E-4E27-ACD4-B4E8EDDCE9F8}"/>
               </a:ext>
             </a:extLst>
           </p:cNvPr>
@@ -10577,7 +10577,7 @@
           <p:cNvPr id="4" name="">
             <a:extLst xmlns:a="http://schemas.openxmlformats.org/drawingml/2006/main">
               <a:ext uri="{FF2B5EF4-FFF2-40B4-BE49-F238E27FC236}">
-                <a16:creationId xmlns:a16="http://schemas.microsoft.com/office/drawing/2014/main" id="{F0B4BC1A-DA52-4B75-8343-73B820A31E75}"/>
+                <a16:creationId xmlns:a16="http://schemas.microsoft.com/office/drawing/2014/main" id="{73A47175-C37B-447D-A86C-83773F986D1E}"/>
               </a:ext>
             </a:extLst>
           </p:cNvPr>
@@ -10698,7 +10698,7 @@
           <p:cNvPr id="5" name="">
             <a:extLst xmlns:a="http://schemas.openxmlformats.org/drawingml/2006/main">
               <a:ext uri="{FF2B5EF4-FFF2-40B4-BE49-F238E27FC236}">
-                <a16:creationId xmlns:a16="http://schemas.microsoft.com/office/drawing/2014/main" id="{44D4083C-B9F0-4E12-9F71-B6F6C5B6B0D6}"/>
+                <a16:creationId xmlns:a16="http://schemas.microsoft.com/office/drawing/2014/main" id="{EA445ACE-E908-4607-86F5-8842ED524BE4}"/>
               </a:ext>
             </a:extLst>
           </p:cNvPr>
@@ -10733,7 +10733,7 @@
           <p:cNvPr id="6" name="">
             <a:extLst xmlns:a="http://schemas.openxmlformats.org/drawingml/2006/main">
               <a:ext uri="{FF2B5EF4-FFF2-40B4-BE49-F238E27FC236}">
-                <a16:creationId xmlns:a16="http://schemas.microsoft.com/office/drawing/2014/main" id="{96C9A5B5-5F73-42F8-86BD-8C6B25A0C2F5}"/>
+                <a16:creationId xmlns:a16="http://schemas.microsoft.com/office/drawing/2014/main" id="{B56D3F2A-39C0-4419-B376-DCB0F7F10911}"/>
               </a:ext>
             </a:extLst>
           </p:cNvPr>
@@ -10854,7 +10854,7 @@
           <p:cNvPr id="7" name="">
             <a:extLst xmlns:a="http://schemas.openxmlformats.org/drawingml/2006/main">
               <a:ext uri="{FF2B5EF4-FFF2-40B4-BE49-F238E27FC236}">
-                <a16:creationId xmlns:a16="http://schemas.microsoft.com/office/drawing/2014/main" id="{D917BFBB-2C5B-4AA1-8465-69D57E52128F}"/>
+                <a16:creationId xmlns:a16="http://schemas.microsoft.com/office/drawing/2014/main" id="{0EC4FC70-6F65-4C86-9756-D58DB34ECBF7}"/>
               </a:ext>
             </a:extLst>
           </p:cNvPr>
@@ -10992,7 +10992,7 @@
           <p:cNvPr id="8" name="">
             <a:extLst xmlns:a="http://schemas.openxmlformats.org/drawingml/2006/main">
               <a:ext uri="{FF2B5EF4-FFF2-40B4-BE49-F238E27FC236}">
-                <a16:creationId xmlns:a16="http://schemas.microsoft.com/office/drawing/2014/main" id="{503BD05B-1770-4FC2-8DEB-232464323419}"/>
+                <a16:creationId xmlns:a16="http://schemas.microsoft.com/office/drawing/2014/main" id="{8A360A53-F052-49B2-88DB-1075011F9FF8}"/>
               </a:ext>
             </a:extLst>
           </p:cNvPr>
@@ -11027,7 +11027,7 @@
           <p:cNvPr id="9" name="">
             <a:extLst xmlns:a="http://schemas.openxmlformats.org/drawingml/2006/main">
               <a:ext uri="{FF2B5EF4-FFF2-40B4-BE49-F238E27FC236}">
-                <a16:creationId xmlns:a16="http://schemas.microsoft.com/office/drawing/2014/main" id="{3A93BFCB-A7B3-411F-819B-4BED1E352946}"/>
+                <a16:creationId xmlns:a16="http://schemas.microsoft.com/office/drawing/2014/main" id="{42D06352-E3E9-4455-9EDF-962043C1FE30}"/>
               </a:ext>
             </a:extLst>
           </p:cNvPr>
@@ -11148,7 +11148,7 @@
           <p:cNvPr id="10" name="">
             <a:extLst xmlns:a="http://schemas.openxmlformats.org/drawingml/2006/main">
               <a:ext uri="{FF2B5EF4-FFF2-40B4-BE49-F238E27FC236}">
-                <a16:creationId xmlns:a16="http://schemas.microsoft.com/office/drawing/2014/main" id="{E73E587E-1FD1-4604-A0C9-D04BD69440FD}"/>
+                <a16:creationId xmlns:a16="http://schemas.microsoft.com/office/drawing/2014/main" id="{B1F984D0-E23D-4DEC-8079-C193EF24CF02}"/>
               </a:ext>
             </a:extLst>
           </p:cNvPr>
@@ -11286,7 +11286,7 @@
           <p:cNvPr id="11" name="">
             <a:extLst xmlns:a="http://schemas.openxmlformats.org/drawingml/2006/main">
               <a:ext uri="{FF2B5EF4-FFF2-40B4-BE49-F238E27FC236}">
-                <a16:creationId xmlns:a16="http://schemas.microsoft.com/office/drawing/2014/main" id="{12C8EDCC-E40B-4CF4-9304-C7F170D94902}"/>
+                <a16:creationId xmlns:a16="http://schemas.microsoft.com/office/drawing/2014/main" id="{F212CC4E-D7CD-4FFB-89C2-54BD436D5E85}"/>
               </a:ext>
             </a:extLst>
           </p:cNvPr>
@@ -11321,7 +11321,7 @@
           <p:cNvPr id="12" name="">
             <a:extLst xmlns:a="http://schemas.openxmlformats.org/drawingml/2006/main">
               <a:ext uri="{FF2B5EF4-FFF2-40B4-BE49-F238E27FC236}">
-                <a16:creationId xmlns:a16="http://schemas.microsoft.com/office/drawing/2014/main" id="{F13B4B01-B643-4261-B31E-A07F24B44BC8}"/>
+                <a16:creationId xmlns:a16="http://schemas.microsoft.com/office/drawing/2014/main" id="{8BD28059-1742-4D93-897E-E3CB48FDA7F6}"/>
               </a:ext>
             </a:extLst>
           </p:cNvPr>
@@ -11442,7 +11442,7 @@
           <p:cNvPr id="13" name="">
             <a:extLst xmlns:a="http://schemas.openxmlformats.org/drawingml/2006/main">
               <a:ext uri="{FF2B5EF4-FFF2-40B4-BE49-F238E27FC236}">
-                <a16:creationId xmlns:a16="http://schemas.microsoft.com/office/drawing/2014/main" id="{CDEB4AB7-1CC7-46B5-B580-35A3A1AECF4A}"/>
+                <a16:creationId xmlns:a16="http://schemas.microsoft.com/office/drawing/2014/main" id="{F4F3506B-1C75-4087-B1B7-330901AA4844}"/>
               </a:ext>
             </a:extLst>
           </p:cNvPr>
@@ -11580,7 +11580,7 @@
           <p:cNvPr id="14" name="">
             <a:extLst xmlns:a="http://schemas.openxmlformats.org/drawingml/2006/main">
               <a:ext uri="{FF2B5EF4-FFF2-40B4-BE49-F238E27FC236}">
-                <a16:creationId xmlns:a16="http://schemas.microsoft.com/office/drawing/2014/main" id="{743C9AC9-DC58-4FEA-B03F-7B9558CAEBD2}"/>
+                <a16:creationId xmlns:a16="http://schemas.microsoft.com/office/drawing/2014/main" id="{DADC751E-2C4F-47AC-9284-293A4A743FAC}"/>
               </a:ext>
             </a:extLst>
           </p:cNvPr>
@@ -11615,7 +11615,7 @@
           <p:cNvPr id="15" name="">
             <a:extLst xmlns:a="http://schemas.openxmlformats.org/drawingml/2006/main">
               <a:ext uri="{FF2B5EF4-FFF2-40B4-BE49-F238E27FC236}">
-                <a16:creationId xmlns:a16="http://schemas.microsoft.com/office/drawing/2014/main" id="{E860FA4D-1DA8-4C97-81FE-3DD377138D0C}"/>
+                <a16:creationId xmlns:a16="http://schemas.microsoft.com/office/drawing/2014/main" id="{31A4A876-E4BF-4955-AEFC-589CD8ACDC5F}"/>
               </a:ext>
             </a:extLst>
           </p:cNvPr>
@@ -11736,7 +11736,7 @@
           <p:cNvPr id="16" name="">
             <a:extLst xmlns:a="http://schemas.openxmlformats.org/drawingml/2006/main">
               <a:ext uri="{FF2B5EF4-FFF2-40B4-BE49-F238E27FC236}">
-                <a16:creationId xmlns:a16="http://schemas.microsoft.com/office/drawing/2014/main" id="{4DDC6472-B186-43B0-998B-1DB68C73886B}"/>
+                <a16:creationId xmlns:a16="http://schemas.microsoft.com/office/drawing/2014/main" id="{52FAC76A-71FA-496C-B4E4-97AC5B3B5525}"/>
               </a:ext>
             </a:extLst>
           </p:cNvPr>
@@ -11874,7 +11874,7 @@
           <p:cNvPr id="17" name="">
             <a:extLst xmlns:a="http://schemas.openxmlformats.org/drawingml/2006/main">
               <a:ext uri="{FF2B5EF4-FFF2-40B4-BE49-F238E27FC236}">
-                <a16:creationId xmlns:a16="http://schemas.microsoft.com/office/drawing/2014/main" id="{F2F9B3DF-1548-4334-AE13-4C991F47F525}"/>
+                <a16:creationId xmlns:a16="http://schemas.microsoft.com/office/drawing/2014/main" id="{E80E02CF-0D5D-400B-95D2-1570B7F956E2}"/>
               </a:ext>
             </a:extLst>
           </p:cNvPr>
@@ -11909,7 +11909,7 @@
           <p:cNvPr id="18" name="">
             <a:extLst xmlns:a="http://schemas.openxmlformats.org/drawingml/2006/main">
               <a:ext uri="{FF2B5EF4-FFF2-40B4-BE49-F238E27FC236}">
-                <a16:creationId xmlns:a16="http://schemas.microsoft.com/office/drawing/2014/main" id="{E1EABA6C-EA38-4884-A08A-C9C358973840}"/>
+                <a16:creationId xmlns:a16="http://schemas.microsoft.com/office/drawing/2014/main" id="{712A6E9F-B607-4248-91EE-0B2885DF6F41}"/>
               </a:ext>
             </a:extLst>
           </p:cNvPr>
@@ -12030,7 +12030,7 @@
           <p:cNvPr id="19" name="">
             <a:extLst xmlns:a="http://schemas.openxmlformats.org/drawingml/2006/main">
               <a:ext uri="{FF2B5EF4-FFF2-40B4-BE49-F238E27FC236}">
-                <a16:creationId xmlns:a16="http://schemas.microsoft.com/office/drawing/2014/main" id="{FA27BCE2-62F6-452B-AA7A-CE60C5AD0AE4}"/>
+                <a16:creationId xmlns:a16="http://schemas.microsoft.com/office/drawing/2014/main" id="{BE0D7D62-F3B1-4B84-BEA4-1976B2E6681D}"/>
               </a:ext>
             </a:extLst>
           </p:cNvPr>
@@ -12061,7 +12061,7 @@
           <p:cNvPr id="20" name="">
             <a:extLst xmlns:a="http://schemas.openxmlformats.org/drawingml/2006/main">
               <a:ext uri="{FF2B5EF4-FFF2-40B4-BE49-F238E27FC236}">
-                <a16:creationId xmlns:a16="http://schemas.microsoft.com/office/drawing/2014/main" id="{0CE7A64C-E705-416C-9592-E625D75C80A3}"/>
+                <a16:creationId xmlns:a16="http://schemas.microsoft.com/office/drawing/2014/main" id="{E93F39C0-A0ED-4066-A195-2DA676E04323}"/>
               </a:ext>
             </a:extLst>
           </p:cNvPr>
@@ -12182,7 +12182,7 @@
           <p:cNvPr id="21" name="">
             <a:extLst xmlns:a="http://schemas.openxmlformats.org/drawingml/2006/main">
               <a:ext uri="{FF2B5EF4-FFF2-40B4-BE49-F238E27FC236}">
-                <a16:creationId xmlns:a16="http://schemas.microsoft.com/office/drawing/2014/main" id="{B7DD8F29-5FFA-48DA-8A31-FCCB5B18CEE8}"/>
+                <a16:creationId xmlns:a16="http://schemas.microsoft.com/office/drawing/2014/main" id="{48609F9A-E541-4504-BF31-85B3E53B5893}"/>
               </a:ext>
             </a:extLst>
           </p:cNvPr>
@@ -12213,7 +12213,7 @@
           <p:cNvPr id="22" name="">
             <a:extLst xmlns:a="http://schemas.openxmlformats.org/drawingml/2006/main">
               <a:ext uri="{FF2B5EF4-FFF2-40B4-BE49-F238E27FC236}">
-                <a16:creationId xmlns:a16="http://schemas.microsoft.com/office/drawing/2014/main" id="{9B793040-8035-4F37-956F-279145AF1442}"/>
+                <a16:creationId xmlns:a16="http://schemas.microsoft.com/office/drawing/2014/main" id="{6301A1A8-38C4-465B-A137-CC2B85FE76B5}"/>
               </a:ext>
             </a:extLst>
           </p:cNvPr>
@@ -12334,7 +12334,7 @@
           <p:cNvPr id="23" name="">
             <a:extLst xmlns:a="http://schemas.openxmlformats.org/drawingml/2006/main">
               <a:ext uri="{FF2B5EF4-FFF2-40B4-BE49-F238E27FC236}">
-                <a16:creationId xmlns:a16="http://schemas.microsoft.com/office/drawing/2014/main" id="{29F16929-FB83-4602-AE81-2059F418D0C5}"/>
+                <a16:creationId xmlns:a16="http://schemas.microsoft.com/office/drawing/2014/main" id="{5523ACAD-5D23-4551-88D7-BA3E7895DE9E}"/>
               </a:ext>
             </a:extLst>
           </p:cNvPr>
@@ -12365,7 +12365,7 @@
           <p:cNvPr id="24" name="">
             <a:extLst xmlns:a="http://schemas.openxmlformats.org/drawingml/2006/main">
               <a:ext uri="{FF2B5EF4-FFF2-40B4-BE49-F238E27FC236}">
-                <a16:creationId xmlns:a16="http://schemas.microsoft.com/office/drawing/2014/main" id="{807FF658-7722-43C7-8BB4-C5CAAE72933F}"/>
+                <a16:creationId xmlns:a16="http://schemas.microsoft.com/office/drawing/2014/main" id="{96F2FDAA-DEAD-4E95-A038-5A394CA42E61}"/>
               </a:ext>
             </a:extLst>
           </p:cNvPr>
@@ -12486,7 +12486,7 @@
           <p:cNvPr id="25" name="">
             <a:extLst xmlns:a="http://schemas.openxmlformats.org/drawingml/2006/main">
               <a:ext uri="{FF2B5EF4-FFF2-40B4-BE49-F238E27FC236}">
-                <a16:creationId xmlns:a16="http://schemas.microsoft.com/office/drawing/2014/main" id="{86D8D0D8-FBB6-41BF-A5B9-5BC16284AD14}"/>
+                <a16:creationId xmlns:a16="http://schemas.microsoft.com/office/drawing/2014/main" id="{137A1868-ACCE-4864-BFA9-C6186822ACD9}"/>
               </a:ext>
             </a:extLst>
           </p:cNvPr>
@@ -12517,7 +12517,7 @@
           <p:cNvPr id="26" name="">
             <a:extLst xmlns:a="http://schemas.openxmlformats.org/drawingml/2006/main">
               <a:ext uri="{FF2B5EF4-FFF2-40B4-BE49-F238E27FC236}">
-                <a16:creationId xmlns:a16="http://schemas.microsoft.com/office/drawing/2014/main" id="{174DEB8F-6F08-4976-AF8D-C666A6EB8436}"/>
+                <a16:creationId xmlns:a16="http://schemas.microsoft.com/office/drawing/2014/main" id="{7F57C15F-7B15-428F-8007-40E0EDF1D8C9}"/>
               </a:ext>
             </a:extLst>
           </p:cNvPr>
@@ -12638,7 +12638,7 @@
           <p:cNvPr id="27" name="">
             <a:extLst xmlns:a="http://schemas.openxmlformats.org/drawingml/2006/main">
               <a:ext uri="{FF2B5EF4-FFF2-40B4-BE49-F238E27FC236}">
-                <a16:creationId xmlns:a16="http://schemas.microsoft.com/office/drawing/2014/main" id="{31AADC3F-7B0B-4334-A514-238A63DCE092}"/>
+                <a16:creationId xmlns:a16="http://schemas.microsoft.com/office/drawing/2014/main" id="{F003450F-BB6E-49EB-989C-8C61211394EB}"/>
               </a:ext>
             </a:extLst>
           </p:cNvPr>
@@ -12673,7 +12673,7 @@
           <p:cNvPr id="28" name="">
             <a:extLst xmlns:a="http://schemas.openxmlformats.org/drawingml/2006/main">
               <a:ext uri="{FF2B5EF4-FFF2-40B4-BE49-F238E27FC236}">
-                <a16:creationId xmlns:a16="http://schemas.microsoft.com/office/drawing/2014/main" id="{A1D37207-674D-45EA-9BC4-0F0048323AF2}"/>
+                <a16:creationId xmlns:a16="http://schemas.microsoft.com/office/drawing/2014/main" id="{C2058B24-FE1E-4FF5-92C5-E061F09602B4}"/>
               </a:ext>
             </a:extLst>
           </p:cNvPr>
@@ -12794,7 +12794,7 @@
           <p:cNvPr id="29" name="">
             <a:extLst xmlns:a="http://schemas.openxmlformats.org/drawingml/2006/main">
               <a:ext uri="{FF2B5EF4-FFF2-40B4-BE49-F238E27FC236}">
-                <a16:creationId xmlns:a16="http://schemas.microsoft.com/office/drawing/2014/main" id="{905AC869-333A-4789-8D27-5B9074B948DC}"/>
+                <a16:creationId xmlns:a16="http://schemas.microsoft.com/office/drawing/2014/main" id="{234A800A-490E-4623-A11E-5742C9197776}"/>
               </a:ext>
             </a:extLst>
           </p:cNvPr>
@@ -12915,7 +12915,7 @@
           <p:cNvPr id="30" name="">
             <a:extLst xmlns:a="http://schemas.openxmlformats.org/drawingml/2006/main">
               <a:ext uri="{FF2B5EF4-FFF2-40B4-BE49-F238E27FC236}">
-                <a16:creationId xmlns:a16="http://schemas.microsoft.com/office/drawing/2014/main" id="{136C3286-6DEF-4AB2-B298-EDBF49B666EB}"/>
+                <a16:creationId xmlns:a16="http://schemas.microsoft.com/office/drawing/2014/main" id="{EF8A4B3A-10F4-43DE-9AD8-9FFAEEAE77DB}"/>
               </a:ext>
             </a:extLst>
           </p:cNvPr>
@@ -13036,7 +13036,7 @@
           <p:cNvPr id="31" name="">
             <a:extLst xmlns:a="http://schemas.openxmlformats.org/drawingml/2006/main">
               <a:ext uri="{FF2B5EF4-FFF2-40B4-BE49-F238E27FC236}">
-                <a16:creationId xmlns:a16="http://schemas.microsoft.com/office/drawing/2014/main" id="{F71325F5-3174-4F3F-96EC-4A69902AD2E1}"/>
+                <a16:creationId xmlns:a16="http://schemas.microsoft.com/office/drawing/2014/main" id="{D05CA23D-F15B-496C-8709-355362DC6E31}"/>
               </a:ext>
             </a:extLst>
           </p:cNvPr>
@@ -13157,7 +13157,7 @@
           <p:cNvPr id="32" name="">
             <a:extLst xmlns:a="http://schemas.openxmlformats.org/drawingml/2006/main">
               <a:ext uri="{FF2B5EF4-FFF2-40B4-BE49-F238E27FC236}">
-                <a16:creationId xmlns:a16="http://schemas.microsoft.com/office/drawing/2014/main" id="{C144B863-158C-4E48-BFDE-E7A270D537F5}"/>
+                <a16:creationId xmlns:a16="http://schemas.microsoft.com/office/drawing/2014/main" id="{EA0B267D-9A0F-4BC9-829A-3A7A09D89D4A}"/>
               </a:ext>
             </a:extLst>
           </p:cNvPr>
@@ -13278,7 +13278,7 @@
           <p:cNvPr id="33" name="">
             <a:extLst xmlns:a="http://schemas.openxmlformats.org/drawingml/2006/main">
               <a:ext uri="{FF2B5EF4-FFF2-40B4-BE49-F238E27FC236}">
-                <a16:creationId xmlns:a16="http://schemas.microsoft.com/office/drawing/2014/main" id="{AC2ADF20-984C-4865-83C4-507A0D5B9AAD}"/>
+                <a16:creationId xmlns:a16="http://schemas.microsoft.com/office/drawing/2014/main" id="{2256E88D-6559-4466-B61B-D6FF9B0EA88F}"/>
               </a:ext>
             </a:extLst>
           </p:cNvPr>
@@ -13399,7 +13399,7 @@
           <p:cNvPr id="34" name="">
             <a:extLst xmlns:a="http://schemas.openxmlformats.org/drawingml/2006/main">
               <a:ext uri="{FF2B5EF4-FFF2-40B4-BE49-F238E27FC236}">
-                <a16:creationId xmlns:a16="http://schemas.microsoft.com/office/drawing/2014/main" id="{F82F5D4A-064A-4925-9B11-25F118DEC8F3}"/>
+                <a16:creationId xmlns:a16="http://schemas.microsoft.com/office/drawing/2014/main" id="{43D399AA-E36C-4297-98A6-2A93338FAC35}"/>
               </a:ext>
             </a:extLst>
           </p:cNvPr>
@@ -13520,7 +13520,7 @@
           <p:cNvPr id="35" name="">
             <a:extLst xmlns:a="http://schemas.openxmlformats.org/drawingml/2006/main">
               <a:ext uri="{FF2B5EF4-FFF2-40B4-BE49-F238E27FC236}">
-                <a16:creationId xmlns:a16="http://schemas.microsoft.com/office/drawing/2014/main" id="{30E6A9FC-C8D5-4FD6-A74A-E313B0BEC9DC}"/>
+                <a16:creationId xmlns:a16="http://schemas.microsoft.com/office/drawing/2014/main" id="{736DDAE7-8B4F-4919-BF66-09FB05051B67}"/>
               </a:ext>
             </a:extLst>
           </p:cNvPr>
@@ -13641,7 +13641,7 @@
           <p:cNvPr id="36" name="">
             <a:extLst xmlns:a="http://schemas.openxmlformats.org/drawingml/2006/main">
               <a:ext uri="{FF2B5EF4-FFF2-40B4-BE49-F238E27FC236}">
-                <a16:creationId xmlns:a16="http://schemas.microsoft.com/office/drawing/2014/main" id="{06DE92DB-CCF1-4429-802F-711B143D4C2F}"/>
+                <a16:creationId xmlns:a16="http://schemas.microsoft.com/office/drawing/2014/main" id="{E574DCF7-E875-4056-AF4F-2165E643DF17}"/>
               </a:ext>
             </a:extLst>
           </p:cNvPr>
@@ -13762,7 +13762,7 @@
           <p:cNvPr id="37" name="">
             <a:extLst xmlns:a="http://schemas.openxmlformats.org/drawingml/2006/main">
               <a:ext uri="{FF2B5EF4-FFF2-40B4-BE49-F238E27FC236}">
-                <a16:creationId xmlns:a16="http://schemas.microsoft.com/office/drawing/2014/main" id="{F24DE65C-0D74-4671-9378-E80D9A293085}"/>
+                <a16:creationId xmlns:a16="http://schemas.microsoft.com/office/drawing/2014/main" id="{3758BFDD-1C35-4BA1-A7A6-2CF100A7BEE0}"/>
               </a:ext>
             </a:extLst>
           </p:cNvPr>
@@ -13881,7 +13881,7 @@
     </p:spTree>
     <p:extLst>
       <p:ext uri="{BB962C8B-B14F-4D97-AF65-F5344CB8AC3E}">
-        <p14:creationId xmlns:p14="http://schemas.microsoft.com/office/powerpoint/2010/main" val="467391376"/>
+        <p14:creationId xmlns:p14="http://schemas.microsoft.com/office/powerpoint/2010/main" val="1949668370"/>
       </p:ext>
     </p:extLst>
   </p:cSld>
@@ -13912,7 +13912,7 @@
           <p:cNvPr id="19" name="">
             <a:extLst xmlns:a="http://schemas.openxmlformats.org/drawingml/2006/main">
               <a:ext uri="{FF2B5EF4-FFF2-40B4-BE49-F238E27FC236}">
-                <a16:creationId xmlns:a16="http://schemas.microsoft.com/office/drawing/2014/main" id="{B98E477A-0A43-4314-B64B-5F6A2CC81382}"/>
+                <a16:creationId xmlns:a16="http://schemas.microsoft.com/office/drawing/2014/main" id="{985602BA-DFC3-44A0-837D-31A760509F5A}"/>
               </a:ext>
             </a:extLst>
           </p:cNvPr>
@@ -14033,7 +14033,7 @@
           <p:cNvPr id="2" name="">
             <a:extLst xmlns:a="http://schemas.openxmlformats.org/drawingml/2006/main">
               <a:ext uri="{FF2B5EF4-FFF2-40B4-BE49-F238E27FC236}">
-                <a16:creationId xmlns:a16="http://schemas.microsoft.com/office/drawing/2014/main" id="{BD6105CF-1CB0-4F4B-8674-82D436E2C04B}"/>
+                <a16:creationId xmlns:a16="http://schemas.microsoft.com/office/drawing/2014/main" id="{C690FE97-6845-49E1-8863-208016308C61}"/>
               </a:ext>
             </a:extLst>
           </p:cNvPr>
@@ -14154,7 +14154,7 @@
           <p:cNvPr id="3" name="">
             <a:extLst xmlns:a="http://schemas.openxmlformats.org/drawingml/2006/main">
               <a:ext uri="{FF2B5EF4-FFF2-40B4-BE49-F238E27FC236}">
-                <a16:creationId xmlns:a16="http://schemas.microsoft.com/office/drawing/2014/main" id="{BAF040F0-4080-41B2-B1C9-8593003CED87}"/>
+                <a16:creationId xmlns:a16="http://schemas.microsoft.com/office/drawing/2014/main" id="{3FE5DBFC-64AA-483F-A5A3-E3C37A13D1FF}"/>
               </a:ext>
             </a:extLst>
           </p:cNvPr>
@@ -14185,7 +14185,7 @@
           <p:cNvPr id="4" name="">
             <a:extLst xmlns:a="http://schemas.openxmlformats.org/drawingml/2006/main">
               <a:ext uri="{FF2B5EF4-FFF2-40B4-BE49-F238E27FC236}">
-                <a16:creationId xmlns:a16="http://schemas.microsoft.com/office/drawing/2014/main" id="{5F2943A0-CCB0-46B6-B263-DD3D80B9668A}"/>
+                <a16:creationId xmlns:a16="http://schemas.microsoft.com/office/drawing/2014/main" id="{65FC0F06-3BF7-4C8E-9051-479FD8044962}"/>
               </a:ext>
             </a:extLst>
           </p:cNvPr>
@@ -14306,7 +14306,7 @@
           <p:cNvPr id="5" name="">
             <a:extLst xmlns:a="http://schemas.openxmlformats.org/drawingml/2006/main">
               <a:ext uri="{FF2B5EF4-FFF2-40B4-BE49-F238E27FC236}">
-                <a16:creationId xmlns:a16="http://schemas.microsoft.com/office/drawing/2014/main" id="{7879A45E-CE54-4AA6-9CD6-149B89676D62}"/>
+                <a16:creationId xmlns:a16="http://schemas.microsoft.com/office/drawing/2014/main" id="{8F1DDDB1-0DD7-49F9-B98E-82491A71DB39}"/>
               </a:ext>
             </a:extLst>
           </p:cNvPr>
@@ -14341,7 +14341,7 @@
           <p:cNvPr id="6" name="">
             <a:extLst xmlns:a="http://schemas.openxmlformats.org/drawingml/2006/main">
               <a:ext uri="{FF2B5EF4-FFF2-40B4-BE49-F238E27FC236}">
-                <a16:creationId xmlns:a16="http://schemas.microsoft.com/office/drawing/2014/main" id="{02F112D9-BF50-431A-BE39-AD288EE09699}"/>
+                <a16:creationId xmlns:a16="http://schemas.microsoft.com/office/drawing/2014/main" id="{0F018CFC-D636-4CD8-9B60-FFF3B8CC0C3E}"/>
               </a:ext>
             </a:extLst>
           </p:cNvPr>
@@ -14351,7 +14351,7 @@
           <p:nvPr/>
         </p:nvPicPr>
         <p:blipFill>
-          <a:blip xmlns:r="http://schemas.openxmlformats.org/officeDocument/2006/relationships" xmlns:a="http://schemas.openxmlformats.org/drawingml/2006/main" r:embed="R35559b3fd4114081"/>
+          <a:blip xmlns:r="http://schemas.openxmlformats.org/officeDocument/2006/relationships" xmlns:a="http://schemas.openxmlformats.org/drawingml/2006/main" r:embed="R3c1527a6cf3e40bf"/>
           <a:srcRect xmlns:a="http://schemas.openxmlformats.org/drawingml/2006/main" l="0" t="5000" r="0" b="17000"/>
           <a:stretch xmlns:a="http://schemas.openxmlformats.org/drawingml/2006/main"/>
         </p:blipFill>
@@ -14372,7 +14372,7 @@
           <p:cNvPr id="7" name="">
             <a:extLst xmlns:a="http://schemas.openxmlformats.org/drawingml/2006/main">
               <a:ext uri="{FF2B5EF4-FFF2-40B4-BE49-F238E27FC236}">
-                <a16:creationId xmlns:a16="http://schemas.microsoft.com/office/drawing/2014/main" id="{73B35DDA-ADE5-4D0C-B723-CAC454C32282}"/>
+                <a16:creationId xmlns:a16="http://schemas.microsoft.com/office/drawing/2014/main" id="{46A19CE8-05D3-4108-B692-9612B068ECB4}"/>
               </a:ext>
             </a:extLst>
           </p:cNvPr>
@@ -14407,7 +14407,7 @@
           <p:cNvPr id="8" name="">
             <a:extLst xmlns:a="http://schemas.openxmlformats.org/drawingml/2006/main">
               <a:ext uri="{FF2B5EF4-FFF2-40B4-BE49-F238E27FC236}">
-                <a16:creationId xmlns:a16="http://schemas.microsoft.com/office/drawing/2014/main" id="{9F7338DF-5171-4C05-A3FF-B029C7EFFC15}"/>
+                <a16:creationId xmlns:a16="http://schemas.microsoft.com/office/drawing/2014/main" id="{06B96DA0-59C9-419F-B251-CB119E03F0F0}"/>
               </a:ext>
             </a:extLst>
           </p:cNvPr>
@@ -14417,7 +14417,7 @@
           <p:nvPr/>
         </p:nvPicPr>
         <p:blipFill>
-          <a:blip xmlns:r="http://schemas.openxmlformats.org/officeDocument/2006/relationships" xmlns:a="http://schemas.openxmlformats.org/drawingml/2006/main" r:embed="R1b11c9c153d5436f"/>
+          <a:blip xmlns:r="http://schemas.openxmlformats.org/officeDocument/2006/relationships" xmlns:a="http://schemas.openxmlformats.org/drawingml/2006/main" r:embed="R656bbc72e8dc402f"/>
           <a:srcRect xmlns:a="http://schemas.openxmlformats.org/drawingml/2006/main" l="0" t="28000" r="0" b="2000"/>
           <a:stretch xmlns:a="http://schemas.openxmlformats.org/drawingml/2006/main"/>
         </p:blipFill>
@@ -14438,7 +14438,7 @@
           <p:cNvPr id="9" name="">
             <a:extLst xmlns:a="http://schemas.openxmlformats.org/drawingml/2006/main">
               <a:ext uri="{FF2B5EF4-FFF2-40B4-BE49-F238E27FC236}">
-                <a16:creationId xmlns:a16="http://schemas.microsoft.com/office/drawing/2014/main" id="{29C984FC-9104-4351-8859-F0F17140E7D6}"/>
+                <a16:creationId xmlns:a16="http://schemas.microsoft.com/office/drawing/2014/main" id="{BA7DDE77-CB6F-4BF1-B802-337C4A366058}"/>
               </a:ext>
             </a:extLst>
           </p:cNvPr>
@@ -14473,7 +14473,7 @@
           <p:cNvPr id="10" name="">
             <a:extLst xmlns:a="http://schemas.openxmlformats.org/drawingml/2006/main">
               <a:ext uri="{FF2B5EF4-FFF2-40B4-BE49-F238E27FC236}">
-                <a16:creationId xmlns:a16="http://schemas.microsoft.com/office/drawing/2014/main" id="{245AC72F-AD66-4ABA-BB69-EB532A567A4C}"/>
+                <a16:creationId xmlns:a16="http://schemas.microsoft.com/office/drawing/2014/main" id="{0993A4C1-164C-444A-8E2C-78CA9BCFA4A9}"/>
               </a:ext>
             </a:extLst>
           </p:cNvPr>
@@ -14594,7 +14594,7 @@
           <p:cNvPr id="11" name="">
             <a:extLst xmlns:a="http://schemas.openxmlformats.org/drawingml/2006/main">
               <a:ext uri="{FF2B5EF4-FFF2-40B4-BE49-F238E27FC236}">
-                <a16:creationId xmlns:a16="http://schemas.microsoft.com/office/drawing/2014/main" id="{07033505-8125-445D-9763-C1601AF2D4E1}"/>
+                <a16:creationId xmlns:a16="http://schemas.microsoft.com/office/drawing/2014/main" id="{36C57670-633E-4E74-BEA4-B33C0FBD76BB}"/>
               </a:ext>
             </a:extLst>
           </p:cNvPr>
@@ -14629,7 +14629,7 @@
           <p:cNvPr id="12" name="">
             <a:extLst xmlns:a="http://schemas.openxmlformats.org/drawingml/2006/main">
               <a:ext uri="{FF2B5EF4-FFF2-40B4-BE49-F238E27FC236}">
-                <a16:creationId xmlns:a16="http://schemas.microsoft.com/office/drawing/2014/main" id="{13BBFB11-3088-4BFB-80B3-2480CED6D52A}"/>
+                <a16:creationId xmlns:a16="http://schemas.microsoft.com/office/drawing/2014/main" id="{608616C6-1E81-4B7D-8F29-59990E81DFF7}"/>
               </a:ext>
             </a:extLst>
           </p:cNvPr>
@@ -14750,7 +14750,7 @@
           <p:cNvPr id="13" name="">
             <a:extLst xmlns:a="http://schemas.openxmlformats.org/drawingml/2006/main">
               <a:ext uri="{FF2B5EF4-FFF2-40B4-BE49-F238E27FC236}">
-                <a16:creationId xmlns:a16="http://schemas.microsoft.com/office/drawing/2014/main" id="{DFED10E4-EB1F-4E46-A912-B78D35E7A376}"/>
+                <a16:creationId xmlns:a16="http://schemas.microsoft.com/office/drawing/2014/main" id="{5CB95930-EA36-462B-8B6D-E10343C6CEBC}"/>
               </a:ext>
             </a:extLst>
           </p:cNvPr>
@@ -14871,7 +14871,7 @@
           <p:cNvPr id="14" name="">
             <a:extLst xmlns:a="http://schemas.openxmlformats.org/drawingml/2006/main">
               <a:ext uri="{FF2B5EF4-FFF2-40B4-BE49-F238E27FC236}">
-                <a16:creationId xmlns:a16="http://schemas.microsoft.com/office/drawing/2014/main" id="{FE14676E-4BF3-4882-9B1B-3CCA34DB108E}"/>
+                <a16:creationId xmlns:a16="http://schemas.microsoft.com/office/drawing/2014/main" id="{BF8B3266-B082-40CD-89A4-325BE93E7CA2}"/>
               </a:ext>
             </a:extLst>
           </p:cNvPr>
@@ -14992,7 +14992,7 @@
           <p:cNvPr id="15" name="">
             <a:extLst xmlns:a="http://schemas.openxmlformats.org/drawingml/2006/main">
               <a:ext uri="{FF2B5EF4-FFF2-40B4-BE49-F238E27FC236}">
-                <a16:creationId xmlns:a16="http://schemas.microsoft.com/office/drawing/2014/main" id="{22B7E0A6-805B-4843-9A90-9F11E280C126}"/>
+                <a16:creationId xmlns:a16="http://schemas.microsoft.com/office/drawing/2014/main" id="{C09AAB0F-FDC2-4E03-9235-5A0C8EEFE8CC}"/>
               </a:ext>
             </a:extLst>
           </p:cNvPr>
@@ -15027,7 +15027,7 @@
           <p:cNvPr id="16" name="">
             <a:extLst xmlns:a="http://schemas.openxmlformats.org/drawingml/2006/main">
               <a:ext uri="{FF2B5EF4-FFF2-40B4-BE49-F238E27FC236}">
-                <a16:creationId xmlns:a16="http://schemas.microsoft.com/office/drawing/2014/main" id="{B037F5F7-2E7D-493E-ADC0-37D769CE9CA8}"/>
+                <a16:creationId xmlns:a16="http://schemas.microsoft.com/office/drawing/2014/main" id="{5DF77BF4-41EF-44DB-8BE6-D140B31C61A1}"/>
               </a:ext>
             </a:extLst>
           </p:cNvPr>
@@ -15148,7 +15148,7 @@
           <p:cNvPr id="17" name="">
             <a:extLst xmlns:a="http://schemas.openxmlformats.org/drawingml/2006/main">
               <a:ext uri="{FF2B5EF4-FFF2-40B4-BE49-F238E27FC236}">
-                <a16:creationId xmlns:a16="http://schemas.microsoft.com/office/drawing/2014/main" id="{D55DF827-124E-4915-BF75-0BC27862F406}"/>
+                <a16:creationId xmlns:a16="http://schemas.microsoft.com/office/drawing/2014/main" id="{42F048D6-5178-4436-8027-9D7A8467FB2E}"/>
               </a:ext>
             </a:extLst>
           </p:cNvPr>
@@ -15269,7 +15269,7 @@
           <p:cNvPr id="18" name="">
             <a:extLst xmlns:a="http://schemas.openxmlformats.org/drawingml/2006/main">
               <a:ext uri="{FF2B5EF4-FFF2-40B4-BE49-F238E27FC236}">
-                <a16:creationId xmlns:a16="http://schemas.microsoft.com/office/drawing/2014/main" id="{3171936F-534B-4228-8A99-A992B9B4829B}"/>
+                <a16:creationId xmlns:a16="http://schemas.microsoft.com/office/drawing/2014/main" id="{1C5269A3-7301-4C70-BE56-6B2042B144C7}"/>
               </a:ext>
             </a:extLst>
           </p:cNvPr>
@@ -15388,7 +15388,7 @@
     </p:spTree>
     <p:extLst>
       <p:ext uri="{BB962C8B-B14F-4D97-AF65-F5344CB8AC3E}">
-        <p14:creationId xmlns:p14="http://schemas.microsoft.com/office/powerpoint/2010/main" val="419923641"/>
+        <p14:creationId xmlns:p14="http://schemas.microsoft.com/office/powerpoint/2010/main" val="2104901670"/>
       </p:ext>
     </p:extLst>
   </p:cSld>
@@ -15419,7 +15419,7 @@
           <p:cNvPr id="22" name="">
             <a:extLst xmlns:a="http://schemas.openxmlformats.org/drawingml/2006/main">
               <a:ext uri="{FF2B5EF4-FFF2-40B4-BE49-F238E27FC236}">
-                <a16:creationId xmlns:a16="http://schemas.microsoft.com/office/drawing/2014/main" id="{2DF51715-BD85-4BB8-B9D4-76FCBCC4115A}"/>
+                <a16:creationId xmlns:a16="http://schemas.microsoft.com/office/drawing/2014/main" id="{B5D189FA-8007-448A-8CC4-632952F17BF6}"/>
               </a:ext>
             </a:extLst>
           </p:cNvPr>
@@ -15540,7 +15540,7 @@
           <p:cNvPr id="2" name="">
             <a:extLst xmlns:a="http://schemas.openxmlformats.org/drawingml/2006/main">
               <a:ext uri="{FF2B5EF4-FFF2-40B4-BE49-F238E27FC236}">
-                <a16:creationId xmlns:a16="http://schemas.microsoft.com/office/drawing/2014/main" id="{D1C40355-094D-4664-A6C6-96B6C25BB568}"/>
+                <a16:creationId xmlns:a16="http://schemas.microsoft.com/office/drawing/2014/main" id="{77B89F45-D854-4F34-89E4-9CAB3376126B}"/>
               </a:ext>
             </a:extLst>
           </p:cNvPr>
@@ -15661,7 +15661,7 @@
           <p:cNvPr id="3" name="">
             <a:extLst xmlns:a="http://schemas.openxmlformats.org/drawingml/2006/main">
               <a:ext uri="{FF2B5EF4-FFF2-40B4-BE49-F238E27FC236}">
-                <a16:creationId xmlns:a16="http://schemas.microsoft.com/office/drawing/2014/main" id="{6BF0BCD0-D4FC-4FF5-AD97-7A16B5B3E06F}"/>
+                <a16:creationId xmlns:a16="http://schemas.microsoft.com/office/drawing/2014/main" id="{530A43B1-EF73-4D4C-A58E-926FCFC70CD7}"/>
               </a:ext>
             </a:extLst>
           </p:cNvPr>
@@ -15692,7 +15692,7 @@
           <p:cNvPr id="4" name="">
             <a:extLst xmlns:a="http://schemas.openxmlformats.org/drawingml/2006/main">
               <a:ext uri="{FF2B5EF4-FFF2-40B4-BE49-F238E27FC236}">
-                <a16:creationId xmlns:a16="http://schemas.microsoft.com/office/drawing/2014/main" id="{263EB16E-5373-4FFF-8F8B-69FE17F942E2}"/>
+                <a16:creationId xmlns:a16="http://schemas.microsoft.com/office/drawing/2014/main" id="{74E80D6F-2BF9-4508-8474-88D86BA814CC}"/>
               </a:ext>
             </a:extLst>
           </p:cNvPr>
@@ -15813,7 +15813,7 @@
           <p:cNvPr id="5" name="">
             <a:extLst xmlns:a="http://schemas.openxmlformats.org/drawingml/2006/main">
               <a:ext uri="{FF2B5EF4-FFF2-40B4-BE49-F238E27FC236}">
-                <a16:creationId xmlns:a16="http://schemas.microsoft.com/office/drawing/2014/main" id="{66545F67-0022-4284-BA3D-FD11A462E627}"/>
+                <a16:creationId xmlns:a16="http://schemas.microsoft.com/office/drawing/2014/main" id="{CA4C2B3B-A4F3-449F-9611-8D75B4BBB4AD}"/>
               </a:ext>
             </a:extLst>
           </p:cNvPr>
@@ -15848,7 +15848,7 @@
           <p:cNvPr id="6" name="">
             <a:extLst xmlns:a="http://schemas.openxmlformats.org/drawingml/2006/main">
               <a:ext uri="{FF2B5EF4-FFF2-40B4-BE49-F238E27FC236}">
-                <a16:creationId xmlns:a16="http://schemas.microsoft.com/office/drawing/2014/main" id="{7926FDA0-10B7-4E89-9B3B-D62328C9C25A}"/>
+                <a16:creationId xmlns:a16="http://schemas.microsoft.com/office/drawing/2014/main" id="{CEDB6D17-F8BC-472B-8C51-07BFB8B2F932}"/>
               </a:ext>
             </a:extLst>
           </p:cNvPr>
@@ -15969,7 +15969,7 @@
           <p:cNvPr id="7" name="">
             <a:extLst xmlns:a="http://schemas.openxmlformats.org/drawingml/2006/main">
               <a:ext uri="{FF2B5EF4-FFF2-40B4-BE49-F238E27FC236}">
-                <a16:creationId xmlns:a16="http://schemas.microsoft.com/office/drawing/2014/main" id="{0A400D5E-67FB-4AA4-A03C-57080B9D5203}"/>
+                <a16:creationId xmlns:a16="http://schemas.microsoft.com/office/drawing/2014/main" id="{A277C8A7-33DD-4D28-A364-D8B341292A8C}"/>
               </a:ext>
             </a:extLst>
           </p:cNvPr>
@@ -16107,7 +16107,7 @@
           <p:cNvPr id="8" name="">
             <a:extLst xmlns:a="http://schemas.openxmlformats.org/drawingml/2006/main">
               <a:ext uri="{FF2B5EF4-FFF2-40B4-BE49-F238E27FC236}">
-                <a16:creationId xmlns:a16="http://schemas.microsoft.com/office/drawing/2014/main" id="{E74547E7-C36F-4F06-B10D-8DAB993B97DE}"/>
+                <a16:creationId xmlns:a16="http://schemas.microsoft.com/office/drawing/2014/main" id="{13521F97-49D3-46CF-87F3-ACAB31AFC95C}"/>
               </a:ext>
             </a:extLst>
           </p:cNvPr>
@@ -16142,7 +16142,7 @@
           <p:cNvPr id="9" name="">
             <a:extLst xmlns:a="http://schemas.openxmlformats.org/drawingml/2006/main">
               <a:ext uri="{FF2B5EF4-FFF2-40B4-BE49-F238E27FC236}">
-                <a16:creationId xmlns:a16="http://schemas.microsoft.com/office/drawing/2014/main" id="{9E11FDE6-0913-44A4-9DDC-1ABC272E1CEA}"/>
+                <a16:creationId xmlns:a16="http://schemas.microsoft.com/office/drawing/2014/main" id="{3B1C5517-33C6-415E-9C02-2ABD50FE5061}"/>
               </a:ext>
             </a:extLst>
           </p:cNvPr>
@@ -16263,7 +16263,7 @@
           <p:cNvPr id="10" name="">
             <a:extLst xmlns:a="http://schemas.openxmlformats.org/drawingml/2006/main">
               <a:ext uri="{FF2B5EF4-FFF2-40B4-BE49-F238E27FC236}">
-                <a16:creationId xmlns:a16="http://schemas.microsoft.com/office/drawing/2014/main" id="{E4E3AE8F-BF58-4E81-8996-5A4E872128BA}"/>
+                <a16:creationId xmlns:a16="http://schemas.microsoft.com/office/drawing/2014/main" id="{2A646A4C-4356-4346-9F38-6A7E4428DCF7}"/>
               </a:ext>
             </a:extLst>
           </p:cNvPr>
@@ -16401,7 +16401,7 @@
           <p:cNvPr id="11" name="">
             <a:extLst xmlns:a="http://schemas.openxmlformats.org/drawingml/2006/main">
               <a:ext uri="{FF2B5EF4-FFF2-40B4-BE49-F238E27FC236}">
-                <a16:creationId xmlns:a16="http://schemas.microsoft.com/office/drawing/2014/main" id="{61A389D5-F215-45A6-8D9E-2FF5D8D7D454}"/>
+                <a16:creationId xmlns:a16="http://schemas.microsoft.com/office/drawing/2014/main" id="{6B72B4FA-1ED9-4A5E-AD85-CD694EBDC7E5}"/>
               </a:ext>
             </a:extLst>
           </p:cNvPr>
@@ -16436,7 +16436,7 @@
           <p:cNvPr id="12" name="">
             <a:extLst xmlns:a="http://schemas.openxmlformats.org/drawingml/2006/main">
               <a:ext uri="{FF2B5EF4-FFF2-40B4-BE49-F238E27FC236}">
-                <a16:creationId xmlns:a16="http://schemas.microsoft.com/office/drawing/2014/main" id="{C7EAEE51-FFB4-458E-9A30-F72C53032BEE}"/>
+                <a16:creationId xmlns:a16="http://schemas.microsoft.com/office/drawing/2014/main" id="{850E6D7A-1E42-4D28-913A-F5A5183F4F5A}"/>
               </a:ext>
             </a:extLst>
           </p:cNvPr>
@@ -16557,7 +16557,7 @@
           <p:cNvPr id="13" name="">
             <a:extLst xmlns:a="http://schemas.openxmlformats.org/drawingml/2006/main">
               <a:ext uri="{FF2B5EF4-FFF2-40B4-BE49-F238E27FC236}">
-                <a16:creationId xmlns:a16="http://schemas.microsoft.com/office/drawing/2014/main" id="{495B7931-9AB9-4D1F-B66C-39BF3F2A7AE3}"/>
+                <a16:creationId xmlns:a16="http://schemas.microsoft.com/office/drawing/2014/main" id="{6368C7E4-8E1D-495B-B56E-92A099BAFB94}"/>
               </a:ext>
             </a:extLst>
           </p:cNvPr>
@@ -16695,7 +16695,7 @@
           <p:cNvPr id="14" name="">
             <a:extLst xmlns:a="http://schemas.openxmlformats.org/drawingml/2006/main">
               <a:ext uri="{FF2B5EF4-FFF2-40B4-BE49-F238E27FC236}">
-                <a16:creationId xmlns:a16="http://schemas.microsoft.com/office/drawing/2014/main" id="{AAC82694-69CD-430E-A980-226D2F6B6D47}"/>
+                <a16:creationId xmlns:a16="http://schemas.microsoft.com/office/drawing/2014/main" id="{004D1068-D3E1-4D9A-904C-0ACA17E10E24}"/>
               </a:ext>
             </a:extLst>
           </p:cNvPr>
@@ -16730,7 +16730,7 @@
           <p:cNvPr id="15" name="">
             <a:extLst xmlns:a="http://schemas.openxmlformats.org/drawingml/2006/main">
               <a:ext uri="{FF2B5EF4-FFF2-40B4-BE49-F238E27FC236}">
-                <a16:creationId xmlns:a16="http://schemas.microsoft.com/office/drawing/2014/main" id="{3793A386-BDBF-4029-9F60-CF535880669F}"/>
+                <a16:creationId xmlns:a16="http://schemas.microsoft.com/office/drawing/2014/main" id="{8C92280E-CD47-48DD-A83F-8CABC88790AF}"/>
               </a:ext>
             </a:extLst>
           </p:cNvPr>
@@ -16841,7 +16841,7 @@
                   <a:srgbClr val="46BFC9"/>
                 </a:solidFill>
               </a:rPr>
-              <a:t>283 + 7</a:t>
+              <a:t>294 + 8</a:t>
             </a:r>
           </a:p>
         </p:txBody>
@@ -16851,7 +16851,7 @@
           <p:cNvPr id="16" name="">
             <a:extLst xmlns:a="http://schemas.openxmlformats.org/drawingml/2006/main">
               <a:ext uri="{FF2B5EF4-FFF2-40B4-BE49-F238E27FC236}">
-                <a16:creationId xmlns:a16="http://schemas.microsoft.com/office/drawing/2014/main" id="{A2EA5AA7-91E9-4090-8D09-1AC80A4550F4}"/>
+                <a16:creationId xmlns:a16="http://schemas.microsoft.com/office/drawing/2014/main" id="{B0F287F8-DAAE-4EED-AC4B-61ED6848DDAC}"/>
               </a:ext>
             </a:extLst>
           </p:cNvPr>
@@ -16989,7 +16989,7 @@
           <p:cNvPr id="17" name="">
             <a:extLst xmlns:a="http://schemas.openxmlformats.org/drawingml/2006/main">
               <a:ext uri="{FF2B5EF4-FFF2-40B4-BE49-F238E27FC236}">
-                <a16:creationId xmlns:a16="http://schemas.microsoft.com/office/drawing/2014/main" id="{682375DE-5257-4271-8493-C1D7C5211BD9}"/>
+                <a16:creationId xmlns:a16="http://schemas.microsoft.com/office/drawing/2014/main" id="{7DA8169A-0EA6-4373-BE43-0D84C382C323}"/>
               </a:ext>
             </a:extLst>
           </p:cNvPr>
@@ -17571,7 +17571,7 @@
           <p:cNvPr id="18" name="">
             <a:extLst xmlns:a="http://schemas.openxmlformats.org/drawingml/2006/main">
               <a:ext uri="{FF2B5EF4-FFF2-40B4-BE49-F238E27FC236}">
-                <a16:creationId xmlns:a16="http://schemas.microsoft.com/office/drawing/2014/main" id="{AE095527-E786-43F1-B437-CC915E7099C4}"/>
+                <a16:creationId xmlns:a16="http://schemas.microsoft.com/office/drawing/2014/main" id="{7CFC2CD6-5DDD-436F-BD39-8E9B8307EF9C}"/>
               </a:ext>
             </a:extLst>
           </p:cNvPr>
@@ -17692,7 +17692,7 @@
           <p:cNvPr id="19" name="">
             <a:extLst xmlns:a="http://schemas.openxmlformats.org/drawingml/2006/main">
               <a:ext uri="{FF2B5EF4-FFF2-40B4-BE49-F238E27FC236}">
-                <a16:creationId xmlns:a16="http://schemas.microsoft.com/office/drawing/2014/main" id="{F417B7D9-2C4B-4ADB-A751-8A8D952A512B}"/>
+                <a16:creationId xmlns:a16="http://schemas.microsoft.com/office/drawing/2014/main" id="{7149720D-4761-4441-A03E-A17A832D3321}"/>
               </a:ext>
             </a:extLst>
           </p:cNvPr>
@@ -17813,7 +17813,7 @@
           <p:cNvPr id="20" name="">
             <a:extLst xmlns:a="http://schemas.openxmlformats.org/drawingml/2006/main">
               <a:ext uri="{FF2B5EF4-FFF2-40B4-BE49-F238E27FC236}">
-                <a16:creationId xmlns:a16="http://schemas.microsoft.com/office/drawing/2014/main" id="{4237E272-CCD3-482B-955F-4F22CEBF1139}"/>
+                <a16:creationId xmlns:a16="http://schemas.microsoft.com/office/drawing/2014/main" id="{33CB1219-6A02-44A6-968D-F7F1E5F2A52D}"/>
               </a:ext>
             </a:extLst>
           </p:cNvPr>
@@ -17934,7 +17934,7 @@
           <p:cNvPr id="21" name="">
             <a:extLst xmlns:a="http://schemas.openxmlformats.org/drawingml/2006/main">
               <a:ext uri="{FF2B5EF4-FFF2-40B4-BE49-F238E27FC236}">
-                <a16:creationId xmlns:a16="http://schemas.microsoft.com/office/drawing/2014/main" id="{CD6C8797-4533-4C04-80E3-85FF7BA5813B}"/>
+                <a16:creationId xmlns:a16="http://schemas.microsoft.com/office/drawing/2014/main" id="{471D776E-3C6B-4873-AA65-3DF172C02BC4}"/>
               </a:ext>
             </a:extLst>
           </p:cNvPr>
@@ -18053,7 +18053,7 @@
     </p:spTree>
     <p:extLst>
       <p:ext uri="{BB962C8B-B14F-4D97-AF65-F5344CB8AC3E}">
-        <p14:creationId xmlns:p14="http://schemas.microsoft.com/office/powerpoint/2010/main" val="896810350"/>
+        <p14:creationId xmlns:p14="http://schemas.microsoft.com/office/powerpoint/2010/main" val="1988892158"/>
       </p:ext>
     </p:extLst>
   </p:cSld>
@@ -18084,7 +18084,7 @@
           <p:cNvPr id="24" name="">
             <a:extLst xmlns:a="http://schemas.openxmlformats.org/drawingml/2006/main">
               <a:ext uri="{FF2B5EF4-FFF2-40B4-BE49-F238E27FC236}">
-                <a16:creationId xmlns:a16="http://schemas.microsoft.com/office/drawing/2014/main" id="{C8AA944B-1D56-4959-B531-887F12593B4E}"/>
+                <a16:creationId xmlns:a16="http://schemas.microsoft.com/office/drawing/2014/main" id="{A37CF207-D73A-4AE9-BF68-279439D9F851}"/>
               </a:ext>
             </a:extLst>
           </p:cNvPr>
@@ -18205,7 +18205,7 @@
           <p:cNvPr id="2" name="">
             <a:extLst xmlns:a="http://schemas.openxmlformats.org/drawingml/2006/main">
               <a:ext uri="{FF2B5EF4-FFF2-40B4-BE49-F238E27FC236}">
-                <a16:creationId xmlns:a16="http://schemas.microsoft.com/office/drawing/2014/main" id="{0C16BE1C-8CF4-40DD-BCF7-52A1A9A0E117}"/>
+                <a16:creationId xmlns:a16="http://schemas.microsoft.com/office/drawing/2014/main" id="{4D6E3A5C-7660-4C50-9B2D-7C2FDEC5F7A3}"/>
               </a:ext>
             </a:extLst>
           </p:cNvPr>
@@ -18326,7 +18326,7 @@
           <p:cNvPr id="3" name="">
             <a:extLst xmlns:a="http://schemas.openxmlformats.org/drawingml/2006/main">
               <a:ext uri="{FF2B5EF4-FFF2-40B4-BE49-F238E27FC236}">
-                <a16:creationId xmlns:a16="http://schemas.microsoft.com/office/drawing/2014/main" id="{13CC754A-7E1A-4373-89EB-E4BB6B999442}"/>
+                <a16:creationId xmlns:a16="http://schemas.microsoft.com/office/drawing/2014/main" id="{DFB6D3F7-BD24-41C1-BF5A-7D1C6ACC7D60}"/>
               </a:ext>
             </a:extLst>
           </p:cNvPr>
@@ -18357,7 +18357,7 @@
           <p:cNvPr id="4" name="">
             <a:extLst xmlns:a="http://schemas.openxmlformats.org/drawingml/2006/main">
               <a:ext uri="{FF2B5EF4-FFF2-40B4-BE49-F238E27FC236}">
-                <a16:creationId xmlns:a16="http://schemas.microsoft.com/office/drawing/2014/main" id="{8C8BC296-B736-4F69-AF43-36AE1332DEAC}"/>
+                <a16:creationId xmlns:a16="http://schemas.microsoft.com/office/drawing/2014/main" id="{4E486059-2DF4-4331-ABD6-B64523D95EE7}"/>
               </a:ext>
             </a:extLst>
           </p:cNvPr>
@@ -18478,7 +18478,7 @@
           <p:cNvPr id="5" name="">
             <a:extLst xmlns:a="http://schemas.openxmlformats.org/drawingml/2006/main">
               <a:ext uri="{FF2B5EF4-FFF2-40B4-BE49-F238E27FC236}">
-                <a16:creationId xmlns:a16="http://schemas.microsoft.com/office/drawing/2014/main" id="{7C54494F-4020-4BEB-A22E-BF465A2C74A1}"/>
+                <a16:creationId xmlns:a16="http://schemas.microsoft.com/office/drawing/2014/main" id="{92742CD3-B5C3-4D24-80EC-63C3C39F9281}"/>
               </a:ext>
             </a:extLst>
           </p:cNvPr>
@@ -18513,7 +18513,7 @@
           <p:cNvPr id="6" name="">
             <a:extLst xmlns:a="http://schemas.openxmlformats.org/drawingml/2006/main">
               <a:ext uri="{FF2B5EF4-FFF2-40B4-BE49-F238E27FC236}">
-                <a16:creationId xmlns:a16="http://schemas.microsoft.com/office/drawing/2014/main" id="{DE4E3388-FD40-4172-B702-244E16A65FC7}"/>
+                <a16:creationId xmlns:a16="http://schemas.microsoft.com/office/drawing/2014/main" id="{993E4B0C-66F0-4724-AFA5-1174A4327D5E}"/>
               </a:ext>
             </a:extLst>
           </p:cNvPr>
@@ -18634,7 +18634,7 @@
           <p:cNvPr id="7" name="">
             <a:extLst xmlns:a="http://schemas.openxmlformats.org/drawingml/2006/main">
               <a:ext uri="{FF2B5EF4-FFF2-40B4-BE49-F238E27FC236}">
-                <a16:creationId xmlns:a16="http://schemas.microsoft.com/office/drawing/2014/main" id="{429BF0C0-22B7-4DF0-AA71-6BA11D589133}"/>
+                <a16:creationId xmlns:a16="http://schemas.microsoft.com/office/drawing/2014/main" id="{377281AB-3032-46C5-9E31-6FFB3C01E998}"/>
               </a:ext>
             </a:extLst>
           </p:cNvPr>
@@ -18665,7 +18665,7 @@
           <p:cNvPr id="8" name="">
             <a:extLst xmlns:a="http://schemas.openxmlformats.org/drawingml/2006/main">
               <a:ext uri="{FF2B5EF4-FFF2-40B4-BE49-F238E27FC236}">
-                <a16:creationId xmlns:a16="http://schemas.microsoft.com/office/drawing/2014/main" id="{FE87C1F3-5EB7-4457-9089-E72BD4A9CF7E}"/>
+                <a16:creationId xmlns:a16="http://schemas.microsoft.com/office/drawing/2014/main" id="{1B7E49D4-BE89-439A-9FE7-E2BDBDC7AFCF}"/>
               </a:ext>
             </a:extLst>
           </p:cNvPr>
@@ -18786,7 +18786,7 @@
           <p:cNvPr id="9" name="">
             <a:extLst xmlns:a="http://schemas.openxmlformats.org/drawingml/2006/main">
               <a:ext uri="{FF2B5EF4-FFF2-40B4-BE49-F238E27FC236}">
-                <a16:creationId xmlns:a16="http://schemas.microsoft.com/office/drawing/2014/main" id="{EE5A6F60-FB84-4E80-8430-2257D16AD4C4}"/>
+                <a16:creationId xmlns:a16="http://schemas.microsoft.com/office/drawing/2014/main" id="{FF49E615-B9ED-430A-BC83-2DD5CD45F13E}"/>
               </a:ext>
             </a:extLst>
           </p:cNvPr>
@@ -18817,7 +18817,7 @@
           <p:cNvPr id="10" name="">
             <a:extLst xmlns:a="http://schemas.openxmlformats.org/drawingml/2006/main">
               <a:ext uri="{FF2B5EF4-FFF2-40B4-BE49-F238E27FC236}">
-                <a16:creationId xmlns:a16="http://schemas.microsoft.com/office/drawing/2014/main" id="{9E404D4C-4BA9-47E1-8F2D-CBE805D04B80}"/>
+                <a16:creationId xmlns:a16="http://schemas.microsoft.com/office/drawing/2014/main" id="{8A2B8F73-522D-4A27-A6BD-57C804F28D1E}"/>
               </a:ext>
             </a:extLst>
           </p:cNvPr>
@@ -18938,7 +18938,7 @@
           <p:cNvPr id="11" name="">
             <a:extLst xmlns:a="http://schemas.openxmlformats.org/drawingml/2006/main">
               <a:ext uri="{FF2B5EF4-FFF2-40B4-BE49-F238E27FC236}">
-                <a16:creationId xmlns:a16="http://schemas.microsoft.com/office/drawing/2014/main" id="{22CAF505-24D9-44F3-A169-A8ACD21E3E9D}"/>
+                <a16:creationId xmlns:a16="http://schemas.microsoft.com/office/drawing/2014/main" id="{682AE63C-A0E4-463A-B07E-5378A33DE787}"/>
               </a:ext>
             </a:extLst>
           </p:cNvPr>
@@ -18969,7 +18969,7 @@
           <p:cNvPr id="12" name="">
             <a:extLst xmlns:a="http://schemas.openxmlformats.org/drawingml/2006/main">
               <a:ext uri="{FF2B5EF4-FFF2-40B4-BE49-F238E27FC236}">
-                <a16:creationId xmlns:a16="http://schemas.microsoft.com/office/drawing/2014/main" id="{A4780F35-D188-4DA9-8297-B886791A97B9}"/>
+                <a16:creationId xmlns:a16="http://schemas.microsoft.com/office/drawing/2014/main" id="{03178EA1-4708-444A-9F14-0BAD84937181}"/>
               </a:ext>
             </a:extLst>
           </p:cNvPr>
@@ -19090,7 +19090,7 @@
           <p:cNvPr id="13" name="">
             <a:extLst xmlns:a="http://schemas.openxmlformats.org/drawingml/2006/main">
               <a:ext uri="{FF2B5EF4-FFF2-40B4-BE49-F238E27FC236}">
-                <a16:creationId xmlns:a16="http://schemas.microsoft.com/office/drawing/2014/main" id="{AA3FCB0A-B854-4741-BEFD-5337D49427DD}"/>
+                <a16:creationId xmlns:a16="http://schemas.microsoft.com/office/drawing/2014/main" id="{2AB79FD1-B91B-4038-A5E6-E433ECBFB9A8}"/>
               </a:ext>
             </a:extLst>
           </p:cNvPr>
@@ -19121,7 +19121,7 @@
           <p:cNvPr id="14" name="">
             <a:extLst xmlns:a="http://schemas.openxmlformats.org/drawingml/2006/main">
               <a:ext uri="{FF2B5EF4-FFF2-40B4-BE49-F238E27FC236}">
-                <a16:creationId xmlns:a16="http://schemas.microsoft.com/office/drawing/2014/main" id="{BD067BC2-B2C8-4161-9428-BE5234B58161}"/>
+                <a16:creationId xmlns:a16="http://schemas.microsoft.com/office/drawing/2014/main" id="{DD17BC84-5AE9-4BBF-A6D2-1B757017E967}"/>
               </a:ext>
             </a:extLst>
           </p:cNvPr>
@@ -19242,7 +19242,7 @@
           <p:cNvPr id="15" name="">
             <a:extLst xmlns:a="http://schemas.openxmlformats.org/drawingml/2006/main">
               <a:ext uri="{FF2B5EF4-FFF2-40B4-BE49-F238E27FC236}">
-                <a16:creationId xmlns:a16="http://schemas.microsoft.com/office/drawing/2014/main" id="{E6E54723-C139-4E07-B495-760D4C4B8D6A}"/>
+                <a16:creationId xmlns:a16="http://schemas.microsoft.com/office/drawing/2014/main" id="{FC7AEBEA-FF7A-425D-A870-D1350F8FE5FD}"/>
               </a:ext>
             </a:extLst>
           </p:cNvPr>
@@ -19363,7 +19363,7 @@
           <p:cNvPr id="16" name="">
             <a:extLst xmlns:a="http://schemas.openxmlformats.org/drawingml/2006/main">
               <a:ext uri="{FF2B5EF4-FFF2-40B4-BE49-F238E27FC236}">
-                <a16:creationId xmlns:a16="http://schemas.microsoft.com/office/drawing/2014/main" id="{C0FEB176-828F-488F-A5CE-F6E963B71C3C}"/>
+                <a16:creationId xmlns:a16="http://schemas.microsoft.com/office/drawing/2014/main" id="{A32ECFD7-6A27-4EF5-922D-9C3F66EAFB88}"/>
               </a:ext>
             </a:extLst>
           </p:cNvPr>
@@ -19484,7 +19484,7 @@
           <p:cNvPr id="17" name="">
             <a:extLst xmlns:a="http://schemas.openxmlformats.org/drawingml/2006/main">
               <a:ext uri="{FF2B5EF4-FFF2-40B4-BE49-F238E27FC236}">
-                <a16:creationId xmlns:a16="http://schemas.microsoft.com/office/drawing/2014/main" id="{7BE67958-3FE0-4981-8398-6CB17F282BAA}"/>
+                <a16:creationId xmlns:a16="http://schemas.microsoft.com/office/drawing/2014/main" id="{CB52FB36-7532-4821-BF26-DCD4D7FCEBCE}"/>
               </a:ext>
             </a:extLst>
           </p:cNvPr>
@@ -19519,7 +19519,7 @@
           <p:cNvPr id="18" name="">
             <a:extLst xmlns:a="http://schemas.openxmlformats.org/drawingml/2006/main">
               <a:ext uri="{FF2B5EF4-FFF2-40B4-BE49-F238E27FC236}">
-                <a16:creationId xmlns:a16="http://schemas.microsoft.com/office/drawing/2014/main" id="{80691860-0142-498C-BD1D-ED2BC7EA3601}"/>
+                <a16:creationId xmlns:a16="http://schemas.microsoft.com/office/drawing/2014/main" id="{3CD1938E-5F78-47BC-A56A-A6CB1C3C1625}"/>
               </a:ext>
             </a:extLst>
           </p:cNvPr>
@@ -19529,7 +19529,7 @@
           <p:nvPr/>
         </p:nvPicPr>
         <p:blipFill>
-          <a:blip xmlns:r="http://schemas.openxmlformats.org/officeDocument/2006/relationships" xmlns:a="http://schemas.openxmlformats.org/drawingml/2006/main" r:embed="R77ee4bd3c7874615"/>
+          <a:blip xmlns:r="http://schemas.openxmlformats.org/officeDocument/2006/relationships" xmlns:a="http://schemas.openxmlformats.org/drawingml/2006/main" r:embed="Rad8318e48889463b"/>
           <a:srcRect xmlns:a="http://schemas.openxmlformats.org/drawingml/2006/main" l="36000" t="6000" r="0" b="3000"/>
           <a:stretch xmlns:a="http://schemas.openxmlformats.org/drawingml/2006/main"/>
         </p:blipFill>
@@ -19550,7 +19550,7 @@
           <p:cNvPr id="19" name="">
             <a:extLst xmlns:a="http://schemas.openxmlformats.org/drawingml/2006/main">
               <a:ext uri="{FF2B5EF4-FFF2-40B4-BE49-F238E27FC236}">
-                <a16:creationId xmlns:a16="http://schemas.microsoft.com/office/drawing/2014/main" id="{E8CD4169-B14A-4249-A8C5-781A43134479}"/>
+                <a16:creationId xmlns:a16="http://schemas.microsoft.com/office/drawing/2014/main" id="{AB6C0D62-9F7F-4B60-8335-32ABFA789F93}"/>
               </a:ext>
             </a:extLst>
           </p:cNvPr>
@@ -19585,7 +19585,7 @@
           <p:cNvPr id="20" name="">
             <a:extLst xmlns:a="http://schemas.openxmlformats.org/drawingml/2006/main">
               <a:ext uri="{FF2B5EF4-FFF2-40B4-BE49-F238E27FC236}">
-                <a16:creationId xmlns:a16="http://schemas.microsoft.com/office/drawing/2014/main" id="{D99EBD78-DFBC-4404-94AD-346E09AEDE21}"/>
+                <a16:creationId xmlns:a16="http://schemas.microsoft.com/office/drawing/2014/main" id="{5DDDD2B6-AC5B-4553-8B2B-794730DEF7DF}"/>
               </a:ext>
             </a:extLst>
           </p:cNvPr>
@@ -19706,7 +19706,7 @@
           <p:cNvPr id="21" name="">
             <a:extLst xmlns:a="http://schemas.openxmlformats.org/drawingml/2006/main">
               <a:ext uri="{FF2B5EF4-FFF2-40B4-BE49-F238E27FC236}">
-                <a16:creationId xmlns:a16="http://schemas.microsoft.com/office/drawing/2014/main" id="{817AE551-0CDC-4842-8486-DB8F0D81C7C0}"/>
+                <a16:creationId xmlns:a16="http://schemas.microsoft.com/office/drawing/2014/main" id="{54C1403E-DF0D-4B7A-B8A3-DED5EED4405D}"/>
               </a:ext>
             </a:extLst>
           </p:cNvPr>
@@ -19827,7 +19827,7 @@
           <p:cNvPr id="22" name="">
             <a:extLst xmlns:a="http://schemas.openxmlformats.org/drawingml/2006/main">
               <a:ext uri="{FF2B5EF4-FFF2-40B4-BE49-F238E27FC236}">
-                <a16:creationId xmlns:a16="http://schemas.microsoft.com/office/drawing/2014/main" id="{69399AEE-ED00-4A50-9154-07588FD76390}"/>
+                <a16:creationId xmlns:a16="http://schemas.microsoft.com/office/drawing/2014/main" id="{0E9B5872-B820-4775-BFD9-297C60E0A897}"/>
               </a:ext>
             </a:extLst>
           </p:cNvPr>
@@ -19948,7 +19948,7 @@
           <p:cNvPr id="23" name="">
             <a:extLst xmlns:a="http://schemas.openxmlformats.org/drawingml/2006/main">
               <a:ext uri="{FF2B5EF4-FFF2-40B4-BE49-F238E27FC236}">
-                <a16:creationId xmlns:a16="http://schemas.microsoft.com/office/drawing/2014/main" id="{EC512997-4635-4286-93C1-1C04C06FC0E2}"/>
+                <a16:creationId xmlns:a16="http://schemas.microsoft.com/office/drawing/2014/main" id="{B58C116E-0EB2-4B09-874B-DD8C3E33CDC9}"/>
               </a:ext>
             </a:extLst>
           </p:cNvPr>
@@ -20067,7 +20067,7 @@
     </p:spTree>
     <p:extLst>
       <p:ext uri="{BB962C8B-B14F-4D97-AF65-F5344CB8AC3E}">
-        <p14:creationId xmlns:p14="http://schemas.microsoft.com/office/powerpoint/2010/main" val="549046809"/>
+        <p14:creationId xmlns:p14="http://schemas.microsoft.com/office/powerpoint/2010/main" val="344798526"/>
       </p:ext>
     </p:extLst>
   </p:cSld>

</xml_diff>